<commit_message>
Halve the text of the six technical slides; real-data table on the CPS slide
CPS, supplements, dataset, linking, definitions and examples slides cut
to half their text. The CPS slide now shows four actual records from the
March 2025 supplement (age, longest job last year, weeks, wage, current
occupation, verdict) instead of the descriptive scope table. Alternative
measures lose the description column; examples drop to three cases.

Co-Authored-By: Claude Fable 5 <noreply@anthropic.com>
Claude-Session: https://claude.ai/code/session_01DNzQPDcr3zfLTraMHUHqUn
</commit_message>
<xml_diff>
--- a/report/Proyect_US_v4.pptx
+++ b/report/Proyect_US_v4.pptx
@@ -7495,7 +7495,7 @@
         <p:spPr>
           <a:xfrm>
             <a:off x="777240" y="1691640"/>
-            <a:ext cx="10698480" cy="1188720"/>
+            <a:ext cx="10698480" cy="731520"/>
           </a:xfrm>
           <a:prstGeom prst="rect">
             <a:avLst/>
@@ -7523,7 +7523,7 @@
                 </a:solidFill>
                 <a:latin typeface="Garamond"/>
               </a:rPr>
-              <a:t>The CPS is the household survey from which the official employment and unemployment statistics of the United States are computed. It has been conducted by the Census Bureau for the Bureau of Labor Statistics since 1940.</a:t>
+              <a:t>The monthly household survey behind the official employment statistics: about 60,000 households, the civilian non-institutional population.</a:t>
             </a:r>
           </a:p>
         </p:txBody>
@@ -7536,7 +7536,7 @@
         </p:nvCxnSpPr>
         <p:spPr>
           <a:xfrm>
-            <a:off x="822960" y="3017520"/>
+            <a:off x="822960" y="2743200"/>
             <a:ext cx="10543032" cy="0"/>
           </a:xfrm>
           <a:prstGeom prst="line">
@@ -7571,8 +7571,8 @@
         </p:nvSpPr>
         <p:spPr>
           <a:xfrm>
-            <a:off x="1005840" y="3200400"/>
-            <a:ext cx="1554480" cy="384048"/>
+            <a:off x="960120" y="2871216"/>
+            <a:ext cx="640080" cy="365760"/>
           </a:xfrm>
           <a:prstGeom prst="rect">
             <a:avLst/>
@@ -7587,20 +7587,20 @@
           <a:p>
             <a:pPr algn="l">
               <a:lnSpc>
-                <a:spcPts val="2100"/>
+                <a:spcPts val="1950"/>
               </a:lnSpc>
               <a:spcAft>
                 <a:spcPts val="0"/>
               </a:spcAft>
             </a:pPr>
             <a:r>
-              <a:rPr sz="1400" b="1" i="0">
+              <a:rPr sz="1300" b="1" i="0">
                 <a:solidFill>
                   <a:srgbClr val="26456E"/>
                 </a:solidFill>
                 <a:latin typeface="Garamond"/>
               </a:rPr>
-              <a:t>Scope</a:t>
+              <a:t>Age</a:t>
             </a:r>
           </a:p>
         </p:txBody>
@@ -7613,8 +7613,8 @@
         </p:nvSpPr>
         <p:spPr>
           <a:xfrm>
-            <a:off x="2697480" y="3200400"/>
-            <a:ext cx="8503920" cy="384048"/>
+            <a:off x="1737360" y="2871216"/>
+            <a:ext cx="3017520" cy="365760"/>
           </a:xfrm>
           <a:prstGeom prst="rect">
             <a:avLst/>
@@ -7629,20 +7629,20 @@
           <a:p>
             <a:pPr algn="l">
               <a:lnSpc>
-                <a:spcPts val="2100"/>
+                <a:spcPts val="1950"/>
               </a:lnSpc>
               <a:spcAft>
                 <a:spcPts val="0"/>
               </a:spcAft>
             </a:pPr>
             <a:r>
-              <a:rPr sz="1400" b="0" i="0">
-                <a:solidFill>
-                  <a:srgbClr val="1A2430"/>
+              <a:rPr sz="1300" b="1" i="0">
+                <a:solidFill>
+                  <a:srgbClr val="26456E"/>
                 </a:solidFill>
                 <a:latin typeface="Garamond"/>
               </a:rPr>
-              <a:t>the civilian non-institutional population of the fifty states and the District of Columbia</a:t>
+              <a:t>Longest job last year</a:t>
             </a:r>
           </a:p>
         </p:txBody>
@@ -7655,8 +7655,8 @@
         </p:nvSpPr>
         <p:spPr>
           <a:xfrm>
-            <a:off x="1005840" y="3675887"/>
-            <a:ext cx="1554480" cy="384048"/>
+            <a:off x="4892040" y="2871216"/>
+            <a:ext cx="777240" cy="365760"/>
           </a:xfrm>
           <a:prstGeom prst="rect">
             <a:avLst/>
@@ -7671,20 +7671,20 @@
           <a:p>
             <a:pPr algn="l">
               <a:lnSpc>
-                <a:spcPts val="2100"/>
+                <a:spcPts val="1950"/>
               </a:lnSpc>
               <a:spcAft>
                 <a:spcPts val="0"/>
               </a:spcAft>
             </a:pPr>
             <a:r>
-              <a:rPr sz="1400" b="1" i="0">
+              <a:rPr sz="1300" b="1" i="0">
                 <a:solidFill>
                   <a:srgbClr val="26456E"/>
                 </a:solidFill>
                 <a:latin typeface="Garamond"/>
               </a:rPr>
-              <a:t>Frequency</a:t>
+              <a:t>Weeks</a:t>
             </a:r>
           </a:p>
         </p:txBody>
@@ -7697,8 +7697,8 @@
         </p:nvSpPr>
         <p:spPr>
           <a:xfrm>
-            <a:off x="2697480" y="3675887"/>
-            <a:ext cx="8503920" cy="384048"/>
+            <a:off x="5806440" y="2871216"/>
+            <a:ext cx="1097280" cy="365760"/>
           </a:xfrm>
           <a:prstGeom prst="rect">
             <a:avLst/>
@@ -7713,20 +7713,20 @@
           <a:p>
             <a:pPr algn="l">
               <a:lnSpc>
-                <a:spcPts val="2100"/>
+                <a:spcPts val="1950"/>
               </a:lnSpc>
               <a:spcAft>
                 <a:spcPts val="0"/>
               </a:spcAft>
             </a:pPr>
             <a:r>
-              <a:rPr sz="1400" b="0" i="0">
-                <a:solidFill>
-                  <a:srgbClr val="1A2430"/>
+              <a:rPr sz="1300" b="1" i="0">
+                <a:solidFill>
+                  <a:srgbClr val="26456E"/>
                 </a:solidFill>
                 <a:latin typeface="Garamond"/>
               </a:rPr>
-              <a:t>monthly, with a single reference week in every month</a:t>
+              <a:t>Wage</a:t>
             </a:r>
           </a:p>
         </p:txBody>
@@ -7739,8 +7739,8 @@
         </p:nvSpPr>
         <p:spPr>
           <a:xfrm>
-            <a:off x="1005840" y="4151375"/>
-            <a:ext cx="1554480" cy="384048"/>
+            <a:off x="7040880" y="2871216"/>
+            <a:ext cx="3017520" cy="365760"/>
           </a:xfrm>
           <a:prstGeom prst="rect">
             <a:avLst/>
@@ -7755,165 +7755,39 @@
           <a:p>
             <a:pPr algn="l">
               <a:lnSpc>
-                <a:spcPts val="2100"/>
+                <a:spcPts val="1950"/>
               </a:lnSpc>
               <a:spcAft>
                 <a:spcPts val="0"/>
               </a:spcAft>
             </a:pPr>
             <a:r>
-              <a:rPr sz="1400" b="1" i="0">
+              <a:rPr sz="1300" b="1" i="0">
                 <a:solidFill>
                   <a:srgbClr val="26456E"/>
                 </a:solidFill>
                 <a:latin typeface="Garamond"/>
               </a:rPr>
-              <a:t>Sample</a:t>
-            </a:r>
-          </a:p>
-        </p:txBody>
-      </p:sp>
-      <p:sp>
-        <p:nvSpPr>
-          <p:cNvPr id="11" name="TextBox 10"/>
-          <p:cNvSpPr txBox="1"/>
-          <p:nvPr/>
-        </p:nvSpPr>
-        <p:spPr>
-          <a:xfrm>
-            <a:off x="2697480" y="4151375"/>
-            <a:ext cx="8503920" cy="384048"/>
-          </a:xfrm>
-          <a:prstGeom prst="rect">
-            <a:avLst/>
-          </a:prstGeom>
-          <a:noFill/>
-        </p:spPr>
-        <p:txBody>
-          <a:bodyPr wrap="square" lIns="0" rIns="0" tIns="0" bIns="0">
-            <a:spAutoFit/>
-          </a:bodyPr>
-          <a:lstStyle/>
-          <a:p>
-            <a:pPr algn="l">
-              <a:lnSpc>
-                <a:spcPts val="2100"/>
-              </a:lnSpc>
-              <a:spcAft>
-                <a:spcPts val="0"/>
-              </a:spcAft>
-            </a:pPr>
-            <a:r>
-              <a:rPr sz="1400" b="0" i="0">
-                <a:solidFill>
-                  <a:srgbClr val="1A2430"/>
-                </a:solidFill>
-                <a:latin typeface="Garamond"/>
-              </a:rPr>
-              <a:t>about 60,000 households, some 110,000 individuals, in each monthly round</a:t>
-            </a:r>
-          </a:p>
-        </p:txBody>
-      </p:sp>
-      <p:sp>
-        <p:nvSpPr>
-          <p:cNvPr id="12" name="TextBox 11"/>
-          <p:cNvSpPr txBox="1"/>
-          <p:nvPr/>
-        </p:nvSpPr>
-        <p:spPr>
-          <a:xfrm>
-            <a:off x="1005840" y="4626863"/>
-            <a:ext cx="1554480" cy="384048"/>
-          </a:xfrm>
-          <a:prstGeom prst="rect">
-            <a:avLst/>
-          </a:prstGeom>
-          <a:noFill/>
-        </p:spPr>
-        <p:txBody>
-          <a:bodyPr wrap="square" lIns="0" rIns="0" tIns="0" bIns="0">
-            <a:spAutoFit/>
-          </a:bodyPr>
-          <a:lstStyle/>
-          <a:p>
-            <a:pPr algn="l">
-              <a:lnSpc>
-                <a:spcPts val="2100"/>
-              </a:lnSpc>
-              <a:spcAft>
-                <a:spcPts val="0"/>
-              </a:spcAft>
-            </a:pPr>
-            <a:r>
-              <a:rPr sz="1400" b="1" i="0">
-                <a:solidFill>
-                  <a:srgbClr val="26456E"/>
-                </a:solidFill>
-                <a:latin typeface="Garamond"/>
-              </a:rPr>
-              <a:t>Rotation</a:t>
-            </a:r>
-          </a:p>
-        </p:txBody>
-      </p:sp>
-      <p:sp>
-        <p:nvSpPr>
-          <p:cNvPr id="13" name="TextBox 12"/>
-          <p:cNvSpPr txBox="1"/>
-          <p:nvPr/>
-        </p:nvSpPr>
-        <p:spPr>
-          <a:xfrm>
-            <a:off x="2697480" y="4626863"/>
-            <a:ext cx="8503920" cy="384048"/>
-          </a:xfrm>
-          <a:prstGeom prst="rect">
-            <a:avLst/>
-          </a:prstGeom>
-          <a:noFill/>
-        </p:spPr>
-        <p:txBody>
-          <a:bodyPr wrap="square" lIns="0" rIns="0" tIns="0" bIns="0">
-            <a:spAutoFit/>
-          </a:bodyPr>
-          <a:lstStyle/>
-          <a:p>
-            <a:pPr algn="l">
-              <a:lnSpc>
-                <a:spcPts val="2100"/>
-              </a:lnSpc>
-              <a:spcAft>
-                <a:spcPts val="0"/>
-              </a:spcAft>
-            </a:pPr>
-            <a:r>
-              <a:rPr sz="1400" b="0" i="0">
-                <a:solidFill>
-                  <a:srgbClr val="1A2430"/>
-                </a:solidFill>
-                <a:latin typeface="Garamond"/>
-              </a:rPr>
-              <a:t>four monthly interviews, eight months out, four more: eight interviews over sixteen months</a:t>
+              <a:t>Occupation this March</a:t>
             </a:r>
           </a:p>
         </p:txBody>
       </p:sp>
       <p:cxnSp>
         <p:nvCxnSpPr>
-          <p:cNvPr id="14" name="Connector 13"/>
+          <p:cNvPr id="11" name="Connector 10"/>
           <p:cNvCxnSpPr/>
           <p:nvPr/>
         </p:nvCxnSpPr>
         <p:spPr>
           <a:xfrm>
-            <a:off x="822960" y="5148071"/>
+            <a:off x="822960" y="3255264"/>
             <a:ext cx="10543032" cy="0"/>
           </a:xfrm>
           <a:prstGeom prst="line">
             <a:avLst/>
           </a:prstGeom>
-          <a:ln w="12700">
+          <a:ln w="7620">
             <a:solidFill>
               <a:srgbClr val="1A2430"/>
             </a:solidFill>
@@ -7936,14 +7810,14 @@
       </p:cxnSp>
       <p:sp>
         <p:nvSpPr>
-          <p:cNvPr id="15" name="TextBox 14"/>
+          <p:cNvPr id="12" name="TextBox 11"/>
           <p:cNvSpPr txBox="1"/>
           <p:nvPr/>
         </p:nvSpPr>
         <p:spPr>
           <a:xfrm>
-            <a:off x="777240" y="5422391"/>
-            <a:ext cx="10698480" cy="914400"/>
+            <a:off x="960120" y="3401568"/>
+            <a:ext cx="640080" cy="384048"/>
           </a:xfrm>
           <a:prstGeom prst="rect">
             <a:avLst/>
@@ -7956,22 +7830,1065 @@
           </a:bodyPr>
           <a:lstStyle/>
           <a:p>
-            <a:pPr algn="just">
+            <a:pPr algn="l">
               <a:lnSpc>
-                <a:spcPts val="2250"/>
+                <a:spcPts val="1875"/>
               </a:lnSpc>
               <a:spcAft>
                 <a:spcPts val="0"/>
               </a:spcAft>
             </a:pPr>
             <a:r>
-              <a:rPr sz="1500" b="0" i="0">
+              <a:rPr sz="1250" b="0" i="0">
                 <a:solidFill>
                   <a:srgbClr val="1A2430"/>
                 </a:solidFill>
                 <a:latin typeface="Garamond"/>
               </a:rPr>
-              <a:t>The rotation is the property this paper exploits: because a household returns to the sample exactly one year after its first interviews, the same individual can be observed twelve months apart.</a:t>
+              <a:t>58</a:t>
+            </a:r>
+          </a:p>
+        </p:txBody>
+      </p:sp>
+      <p:sp>
+        <p:nvSpPr>
+          <p:cNvPr id="13" name="TextBox 12"/>
+          <p:cNvSpPr txBox="1"/>
+          <p:nvPr/>
+        </p:nvSpPr>
+        <p:spPr>
+          <a:xfrm>
+            <a:off x="1737360" y="3401568"/>
+            <a:ext cx="3017520" cy="384048"/>
+          </a:xfrm>
+          <a:prstGeom prst="rect">
+            <a:avLst/>
+          </a:prstGeom>
+          <a:noFill/>
+        </p:spPr>
+        <p:txBody>
+          <a:bodyPr wrap="square" lIns="0" rIns="0" tIns="0" bIns="0">
+            <a:spAutoFit/>
+          </a:bodyPr>
+          <a:lstStyle/>
+          <a:p>
+            <a:pPr algn="l">
+              <a:lnSpc>
+                <a:spcPts val="1875"/>
+              </a:lnSpc>
+              <a:spcAft>
+                <a:spcPts val="0"/>
+              </a:spcAft>
+            </a:pPr>
+            <a:r>
+              <a:rPr sz="1250" b="0" i="0">
+                <a:solidFill>
+                  <a:srgbClr val="1A2430"/>
+                </a:solidFill>
+                <a:latin typeface="Garamond"/>
+              </a:rPr>
+              <a:t>Elementary and middle school teachers</a:t>
+            </a:r>
+          </a:p>
+        </p:txBody>
+      </p:sp>
+      <p:sp>
+        <p:nvSpPr>
+          <p:cNvPr id="14" name="TextBox 13"/>
+          <p:cNvSpPr txBox="1"/>
+          <p:nvPr/>
+        </p:nvSpPr>
+        <p:spPr>
+          <a:xfrm>
+            <a:off x="4892040" y="3401568"/>
+            <a:ext cx="777240" cy="384048"/>
+          </a:xfrm>
+          <a:prstGeom prst="rect">
+            <a:avLst/>
+          </a:prstGeom>
+          <a:noFill/>
+        </p:spPr>
+        <p:txBody>
+          <a:bodyPr wrap="square" lIns="0" rIns="0" tIns="0" bIns="0">
+            <a:spAutoFit/>
+          </a:bodyPr>
+          <a:lstStyle/>
+          <a:p>
+            <a:pPr algn="l">
+              <a:lnSpc>
+                <a:spcPts val="1875"/>
+              </a:lnSpc>
+              <a:spcAft>
+                <a:spcPts val="0"/>
+              </a:spcAft>
+            </a:pPr>
+            <a:r>
+              <a:rPr sz="1250" b="0" i="0">
+                <a:solidFill>
+                  <a:srgbClr val="1A2430"/>
+                </a:solidFill>
+                <a:latin typeface="Garamond"/>
+              </a:rPr>
+              <a:t>52</a:t>
+            </a:r>
+          </a:p>
+        </p:txBody>
+      </p:sp>
+      <p:sp>
+        <p:nvSpPr>
+          <p:cNvPr id="15" name="TextBox 14"/>
+          <p:cNvSpPr txBox="1"/>
+          <p:nvPr/>
+        </p:nvSpPr>
+        <p:spPr>
+          <a:xfrm>
+            <a:off x="5806440" y="3401568"/>
+            <a:ext cx="1097280" cy="384048"/>
+          </a:xfrm>
+          <a:prstGeom prst="rect">
+            <a:avLst/>
+          </a:prstGeom>
+          <a:noFill/>
+        </p:spPr>
+        <p:txBody>
+          <a:bodyPr wrap="square" lIns="0" rIns="0" tIns="0" bIns="0">
+            <a:spAutoFit/>
+          </a:bodyPr>
+          <a:lstStyle/>
+          <a:p>
+            <a:pPr algn="l">
+              <a:lnSpc>
+                <a:spcPts val="1875"/>
+              </a:lnSpc>
+              <a:spcAft>
+                <a:spcPts val="0"/>
+              </a:spcAft>
+            </a:pPr>
+            <a:r>
+              <a:rPr sz="1250" b="0" i="0">
+                <a:solidFill>
+                  <a:srgbClr val="1A2430"/>
+                </a:solidFill>
+                <a:latin typeface="Garamond"/>
+              </a:rPr>
+              <a:t>$76,375</a:t>
+            </a:r>
+          </a:p>
+        </p:txBody>
+      </p:sp>
+      <p:sp>
+        <p:nvSpPr>
+          <p:cNvPr id="16" name="TextBox 15"/>
+          <p:cNvSpPr txBox="1"/>
+          <p:nvPr/>
+        </p:nvSpPr>
+        <p:spPr>
+          <a:xfrm>
+            <a:off x="7040880" y="3401568"/>
+            <a:ext cx="3017520" cy="384048"/>
+          </a:xfrm>
+          <a:prstGeom prst="rect">
+            <a:avLst/>
+          </a:prstGeom>
+          <a:noFill/>
+        </p:spPr>
+        <p:txBody>
+          <a:bodyPr wrap="square" lIns="0" rIns="0" tIns="0" bIns="0">
+            <a:spAutoFit/>
+          </a:bodyPr>
+          <a:lstStyle/>
+          <a:p>
+            <a:pPr algn="l">
+              <a:lnSpc>
+                <a:spcPts val="1875"/>
+              </a:lnSpc>
+              <a:spcAft>
+                <a:spcPts val="0"/>
+              </a:spcAft>
+            </a:pPr>
+            <a:r>
+              <a:rPr sz="1250" b="0" i="0">
+                <a:solidFill>
+                  <a:srgbClr val="1A2430"/>
+                </a:solidFill>
+                <a:latin typeface="Garamond"/>
+              </a:rPr>
+              <a:t>Elementary and middle school teachers</a:t>
+            </a:r>
+          </a:p>
+        </p:txBody>
+      </p:sp>
+      <p:sp>
+        <p:nvSpPr>
+          <p:cNvPr id="17" name="TextBox 16"/>
+          <p:cNvSpPr txBox="1"/>
+          <p:nvPr/>
+        </p:nvSpPr>
+        <p:spPr>
+          <a:xfrm>
+            <a:off x="10195560" y="3401568"/>
+            <a:ext cx="1143000" cy="384048"/>
+          </a:xfrm>
+          <a:prstGeom prst="rect">
+            <a:avLst/>
+          </a:prstGeom>
+          <a:noFill/>
+        </p:spPr>
+        <p:txBody>
+          <a:bodyPr wrap="square" lIns="0" rIns="0" tIns="0" bIns="0">
+            <a:spAutoFit/>
+          </a:bodyPr>
+          <a:lstStyle/>
+          <a:p>
+            <a:pPr algn="l">
+              <a:lnSpc>
+                <a:spcPts val="1875"/>
+              </a:lnSpc>
+              <a:spcAft>
+                <a:spcPts val="0"/>
+              </a:spcAft>
+            </a:pPr>
+            <a:r>
+              <a:rPr sz="1250" b="1" i="0">
+                <a:solidFill>
+                  <a:srgbClr val="1F3864"/>
+                </a:solidFill>
+                <a:latin typeface="Garamond"/>
+              </a:rPr>
+              <a:t>stayer</a:t>
+            </a:r>
+          </a:p>
+        </p:txBody>
+      </p:sp>
+      <p:sp>
+        <p:nvSpPr>
+          <p:cNvPr id="18" name="TextBox 17"/>
+          <p:cNvSpPr txBox="1"/>
+          <p:nvPr/>
+        </p:nvSpPr>
+        <p:spPr>
+          <a:xfrm>
+            <a:off x="960120" y="3877056"/>
+            <a:ext cx="640080" cy="384048"/>
+          </a:xfrm>
+          <a:prstGeom prst="rect">
+            <a:avLst/>
+          </a:prstGeom>
+          <a:noFill/>
+        </p:spPr>
+        <p:txBody>
+          <a:bodyPr wrap="square" lIns="0" rIns="0" tIns="0" bIns="0">
+            <a:spAutoFit/>
+          </a:bodyPr>
+          <a:lstStyle/>
+          <a:p>
+            <a:pPr algn="l">
+              <a:lnSpc>
+                <a:spcPts val="1875"/>
+              </a:lnSpc>
+              <a:spcAft>
+                <a:spcPts val="0"/>
+              </a:spcAft>
+            </a:pPr>
+            <a:r>
+              <a:rPr sz="1250" b="0" i="0">
+                <a:solidFill>
+                  <a:srgbClr val="1A2430"/>
+                </a:solidFill>
+                <a:latin typeface="Garamond"/>
+              </a:rPr>
+              <a:t>28</a:t>
+            </a:r>
+          </a:p>
+        </p:txBody>
+      </p:sp>
+      <p:sp>
+        <p:nvSpPr>
+          <p:cNvPr id="19" name="TextBox 18"/>
+          <p:cNvSpPr txBox="1"/>
+          <p:nvPr/>
+        </p:nvSpPr>
+        <p:spPr>
+          <a:xfrm>
+            <a:off x="1737360" y="3877056"/>
+            <a:ext cx="3017520" cy="384048"/>
+          </a:xfrm>
+          <a:prstGeom prst="rect">
+            <a:avLst/>
+          </a:prstGeom>
+          <a:noFill/>
+        </p:spPr>
+        <p:txBody>
+          <a:bodyPr wrap="square" lIns="0" rIns="0" tIns="0" bIns="0">
+            <a:spAutoFit/>
+          </a:bodyPr>
+          <a:lstStyle/>
+          <a:p>
+            <a:pPr algn="l">
+              <a:lnSpc>
+                <a:spcPts val="1875"/>
+              </a:lnSpc>
+              <a:spcAft>
+                <a:spcPts val="0"/>
+              </a:spcAft>
+            </a:pPr>
+            <a:r>
+              <a:rPr sz="1250" b="0" i="0">
+                <a:solidFill>
+                  <a:srgbClr val="1A2430"/>
+                </a:solidFill>
+                <a:latin typeface="Garamond"/>
+              </a:rPr>
+              <a:t>Elementary and middle school teachers</a:t>
+            </a:r>
+          </a:p>
+        </p:txBody>
+      </p:sp>
+      <p:sp>
+        <p:nvSpPr>
+          <p:cNvPr id="20" name="TextBox 19"/>
+          <p:cNvSpPr txBox="1"/>
+          <p:nvPr/>
+        </p:nvSpPr>
+        <p:spPr>
+          <a:xfrm>
+            <a:off x="4892040" y="3877056"/>
+            <a:ext cx="777240" cy="384048"/>
+          </a:xfrm>
+          <a:prstGeom prst="rect">
+            <a:avLst/>
+          </a:prstGeom>
+          <a:noFill/>
+        </p:spPr>
+        <p:txBody>
+          <a:bodyPr wrap="square" lIns="0" rIns="0" tIns="0" bIns="0">
+            <a:spAutoFit/>
+          </a:bodyPr>
+          <a:lstStyle/>
+          <a:p>
+            <a:pPr algn="l">
+              <a:lnSpc>
+                <a:spcPts val="1875"/>
+              </a:lnSpc>
+              <a:spcAft>
+                <a:spcPts val="0"/>
+              </a:spcAft>
+            </a:pPr>
+            <a:r>
+              <a:rPr sz="1250" b="0" i="0">
+                <a:solidFill>
+                  <a:srgbClr val="1A2430"/>
+                </a:solidFill>
+                <a:latin typeface="Garamond"/>
+              </a:rPr>
+              <a:t>52</a:t>
+            </a:r>
+          </a:p>
+        </p:txBody>
+      </p:sp>
+      <p:sp>
+        <p:nvSpPr>
+          <p:cNvPr id="21" name="TextBox 20"/>
+          <p:cNvSpPr txBox="1"/>
+          <p:nvPr/>
+        </p:nvSpPr>
+        <p:spPr>
+          <a:xfrm>
+            <a:off x="5806440" y="3877056"/>
+            <a:ext cx="1097280" cy="384048"/>
+          </a:xfrm>
+          <a:prstGeom prst="rect">
+            <a:avLst/>
+          </a:prstGeom>
+          <a:noFill/>
+        </p:spPr>
+        <p:txBody>
+          <a:bodyPr wrap="square" lIns="0" rIns="0" tIns="0" bIns="0">
+            <a:spAutoFit/>
+          </a:bodyPr>
+          <a:lstStyle/>
+          <a:p>
+            <a:pPr algn="l">
+              <a:lnSpc>
+                <a:spcPts val="1875"/>
+              </a:lnSpc>
+              <a:spcAft>
+                <a:spcPts val="0"/>
+              </a:spcAft>
+            </a:pPr>
+            <a:r>
+              <a:rPr sz="1250" b="0" i="0">
+                <a:solidFill>
+                  <a:srgbClr val="1A2430"/>
+                </a:solidFill>
+                <a:latin typeface="Garamond"/>
+              </a:rPr>
+              <a:t>$57,000</a:t>
+            </a:r>
+          </a:p>
+        </p:txBody>
+      </p:sp>
+      <p:sp>
+        <p:nvSpPr>
+          <p:cNvPr id="22" name="TextBox 21"/>
+          <p:cNvSpPr txBox="1"/>
+          <p:nvPr/>
+        </p:nvSpPr>
+        <p:spPr>
+          <a:xfrm>
+            <a:off x="7040880" y="3877056"/>
+            <a:ext cx="3017520" cy="384048"/>
+          </a:xfrm>
+          <a:prstGeom prst="rect">
+            <a:avLst/>
+          </a:prstGeom>
+          <a:noFill/>
+        </p:spPr>
+        <p:txBody>
+          <a:bodyPr wrap="square" lIns="0" rIns="0" tIns="0" bIns="0">
+            <a:spAutoFit/>
+          </a:bodyPr>
+          <a:lstStyle/>
+          <a:p>
+            <a:pPr algn="l">
+              <a:lnSpc>
+                <a:spcPts val="1875"/>
+              </a:lnSpc>
+              <a:spcAft>
+                <a:spcPts val="0"/>
+              </a:spcAft>
+            </a:pPr>
+            <a:r>
+              <a:rPr sz="1250" b="0" i="0">
+                <a:solidFill>
+                  <a:srgbClr val="1A2430"/>
+                </a:solidFill>
+                <a:latin typeface="Garamond"/>
+              </a:rPr>
+              <a:t>Secretary and administrative assistant</a:t>
+            </a:r>
+          </a:p>
+        </p:txBody>
+      </p:sp>
+      <p:sp>
+        <p:nvSpPr>
+          <p:cNvPr id="23" name="TextBox 22"/>
+          <p:cNvSpPr txBox="1"/>
+          <p:nvPr/>
+        </p:nvSpPr>
+        <p:spPr>
+          <a:xfrm>
+            <a:off x="10195560" y="3877056"/>
+            <a:ext cx="1143000" cy="384048"/>
+          </a:xfrm>
+          <a:prstGeom prst="rect">
+            <a:avLst/>
+          </a:prstGeom>
+          <a:noFill/>
+        </p:spPr>
+        <p:txBody>
+          <a:bodyPr wrap="square" lIns="0" rIns="0" tIns="0" bIns="0">
+            <a:spAutoFit/>
+          </a:bodyPr>
+          <a:lstStyle/>
+          <a:p>
+            <a:pPr algn="l">
+              <a:lnSpc>
+                <a:spcPts val="1875"/>
+              </a:lnSpc>
+              <a:spcAft>
+                <a:spcPts val="0"/>
+              </a:spcAft>
+            </a:pPr>
+            <a:r>
+              <a:rPr sz="1250" b="1" i="0">
+                <a:solidFill>
+                  <a:srgbClr val="7B2530"/>
+                </a:solidFill>
+                <a:latin typeface="Garamond"/>
+              </a:rPr>
+              <a:t>leaver</a:t>
+            </a:r>
+          </a:p>
+        </p:txBody>
+      </p:sp>
+      <p:sp>
+        <p:nvSpPr>
+          <p:cNvPr id="24" name="TextBox 23"/>
+          <p:cNvSpPr txBox="1"/>
+          <p:nvPr/>
+        </p:nvSpPr>
+        <p:spPr>
+          <a:xfrm>
+            <a:off x="960120" y="4352544"/>
+            <a:ext cx="640080" cy="384048"/>
+          </a:xfrm>
+          <a:prstGeom prst="rect">
+            <a:avLst/>
+          </a:prstGeom>
+          <a:noFill/>
+        </p:spPr>
+        <p:txBody>
+          <a:bodyPr wrap="square" lIns="0" rIns="0" tIns="0" bIns="0">
+            <a:spAutoFit/>
+          </a:bodyPr>
+          <a:lstStyle/>
+          <a:p>
+            <a:pPr algn="l">
+              <a:lnSpc>
+                <a:spcPts val="1875"/>
+              </a:lnSpc>
+              <a:spcAft>
+                <a:spcPts val="0"/>
+              </a:spcAft>
+            </a:pPr>
+            <a:r>
+              <a:rPr sz="1250" b="0" i="0">
+                <a:solidFill>
+                  <a:srgbClr val="1A2430"/>
+                </a:solidFill>
+                <a:latin typeface="Garamond"/>
+              </a:rPr>
+              <a:t>24</a:t>
+            </a:r>
+          </a:p>
+        </p:txBody>
+      </p:sp>
+      <p:sp>
+        <p:nvSpPr>
+          <p:cNvPr id="25" name="TextBox 24"/>
+          <p:cNvSpPr txBox="1"/>
+          <p:nvPr/>
+        </p:nvSpPr>
+        <p:spPr>
+          <a:xfrm>
+            <a:off x="1737360" y="4352544"/>
+            <a:ext cx="3017520" cy="384048"/>
+          </a:xfrm>
+          <a:prstGeom prst="rect">
+            <a:avLst/>
+          </a:prstGeom>
+          <a:noFill/>
+        </p:spPr>
+        <p:txBody>
+          <a:bodyPr wrap="square" lIns="0" rIns="0" tIns="0" bIns="0">
+            <a:spAutoFit/>
+          </a:bodyPr>
+          <a:lstStyle/>
+          <a:p>
+            <a:pPr algn="l">
+              <a:lnSpc>
+                <a:spcPts val="1875"/>
+              </a:lnSpc>
+              <a:spcAft>
+                <a:spcPts val="0"/>
+              </a:spcAft>
+            </a:pPr>
+            <a:r>
+              <a:rPr sz="1250" b="0" i="0">
+                <a:solidFill>
+                  <a:srgbClr val="1A2430"/>
+                </a:solidFill>
+                <a:latin typeface="Garamond"/>
+              </a:rPr>
+              <a:t>Elementary and middle school teachers</a:t>
+            </a:r>
+          </a:p>
+        </p:txBody>
+      </p:sp>
+      <p:sp>
+        <p:nvSpPr>
+          <p:cNvPr id="26" name="TextBox 25"/>
+          <p:cNvSpPr txBox="1"/>
+          <p:nvPr/>
+        </p:nvSpPr>
+        <p:spPr>
+          <a:xfrm>
+            <a:off x="4892040" y="4352544"/>
+            <a:ext cx="777240" cy="384048"/>
+          </a:xfrm>
+          <a:prstGeom prst="rect">
+            <a:avLst/>
+          </a:prstGeom>
+          <a:noFill/>
+        </p:spPr>
+        <p:txBody>
+          <a:bodyPr wrap="square" lIns="0" rIns="0" tIns="0" bIns="0">
+            <a:spAutoFit/>
+          </a:bodyPr>
+          <a:lstStyle/>
+          <a:p>
+            <a:pPr algn="l">
+              <a:lnSpc>
+                <a:spcPts val="1875"/>
+              </a:lnSpc>
+              <a:spcAft>
+                <a:spcPts val="0"/>
+              </a:spcAft>
+            </a:pPr>
+            <a:r>
+              <a:rPr sz="1250" b="0" i="0">
+                <a:solidFill>
+                  <a:srgbClr val="1A2430"/>
+                </a:solidFill>
+                <a:latin typeface="Garamond"/>
+              </a:rPr>
+              <a:t>40</a:t>
+            </a:r>
+          </a:p>
+        </p:txBody>
+      </p:sp>
+      <p:sp>
+        <p:nvSpPr>
+          <p:cNvPr id="27" name="TextBox 26"/>
+          <p:cNvSpPr txBox="1"/>
+          <p:nvPr/>
+        </p:nvSpPr>
+        <p:spPr>
+          <a:xfrm>
+            <a:off x="5806440" y="4352544"/>
+            <a:ext cx="1097280" cy="384048"/>
+          </a:xfrm>
+          <a:prstGeom prst="rect">
+            <a:avLst/>
+          </a:prstGeom>
+          <a:noFill/>
+        </p:spPr>
+        <p:txBody>
+          <a:bodyPr wrap="square" lIns="0" rIns="0" tIns="0" bIns="0">
+            <a:spAutoFit/>
+          </a:bodyPr>
+          <a:lstStyle/>
+          <a:p>
+            <a:pPr algn="l">
+              <a:lnSpc>
+                <a:spcPts val="1875"/>
+              </a:lnSpc>
+              <a:spcAft>
+                <a:spcPts val="0"/>
+              </a:spcAft>
+            </a:pPr>
+            <a:r>
+              <a:rPr sz="1250" b="0" i="0">
+                <a:solidFill>
+                  <a:srgbClr val="1A2430"/>
+                </a:solidFill>
+                <a:latin typeface="Garamond"/>
+              </a:rPr>
+              <a:t>$81,500</a:t>
+            </a:r>
+          </a:p>
+        </p:txBody>
+      </p:sp>
+      <p:sp>
+        <p:nvSpPr>
+          <p:cNvPr id="28" name="TextBox 27"/>
+          <p:cNvSpPr txBox="1"/>
+          <p:nvPr/>
+        </p:nvSpPr>
+        <p:spPr>
+          <a:xfrm>
+            <a:off x="7040880" y="4352544"/>
+            <a:ext cx="3017520" cy="384048"/>
+          </a:xfrm>
+          <a:prstGeom prst="rect">
+            <a:avLst/>
+          </a:prstGeom>
+          <a:noFill/>
+        </p:spPr>
+        <p:txBody>
+          <a:bodyPr wrap="square" lIns="0" rIns="0" tIns="0" bIns="0">
+            <a:spAutoFit/>
+          </a:bodyPr>
+          <a:lstStyle/>
+          <a:p>
+            <a:pPr algn="l">
+              <a:lnSpc>
+                <a:spcPts val="1875"/>
+              </a:lnSpc>
+              <a:spcAft>
+                <a:spcPts val="0"/>
+              </a:spcAft>
+            </a:pPr>
+            <a:r>
+              <a:rPr sz="1250" b="0" i="0">
+                <a:solidFill>
+                  <a:srgbClr val="1A2430"/>
+                </a:solidFill>
+                <a:latin typeface="Garamond"/>
+              </a:rPr>
+              <a:t>Teaching assistant</a:t>
+            </a:r>
+          </a:p>
+        </p:txBody>
+      </p:sp>
+      <p:sp>
+        <p:nvSpPr>
+          <p:cNvPr id="29" name="TextBox 28"/>
+          <p:cNvSpPr txBox="1"/>
+          <p:nvPr/>
+        </p:nvSpPr>
+        <p:spPr>
+          <a:xfrm>
+            <a:off x="10195560" y="4352544"/>
+            <a:ext cx="1143000" cy="384048"/>
+          </a:xfrm>
+          <a:prstGeom prst="rect">
+            <a:avLst/>
+          </a:prstGeom>
+          <a:noFill/>
+        </p:spPr>
+        <p:txBody>
+          <a:bodyPr wrap="square" lIns="0" rIns="0" tIns="0" bIns="0">
+            <a:spAutoFit/>
+          </a:bodyPr>
+          <a:lstStyle/>
+          <a:p>
+            <a:pPr algn="l">
+              <a:lnSpc>
+                <a:spcPts val="1875"/>
+              </a:lnSpc>
+              <a:spcAft>
+                <a:spcPts val="0"/>
+              </a:spcAft>
+            </a:pPr>
+            <a:r>
+              <a:rPr sz="1250" b="1" i="0">
+                <a:solidFill>
+                  <a:srgbClr val="7B2530"/>
+                </a:solidFill>
+                <a:latin typeface="Garamond"/>
+              </a:rPr>
+              <a:t>leaver</a:t>
+            </a:r>
+          </a:p>
+        </p:txBody>
+      </p:sp>
+      <p:sp>
+        <p:nvSpPr>
+          <p:cNvPr id="30" name="TextBox 29"/>
+          <p:cNvSpPr txBox="1"/>
+          <p:nvPr/>
+        </p:nvSpPr>
+        <p:spPr>
+          <a:xfrm>
+            <a:off x="960120" y="4828031"/>
+            <a:ext cx="640080" cy="384048"/>
+          </a:xfrm>
+          <a:prstGeom prst="rect">
+            <a:avLst/>
+          </a:prstGeom>
+          <a:noFill/>
+        </p:spPr>
+        <p:txBody>
+          <a:bodyPr wrap="square" lIns="0" rIns="0" tIns="0" bIns="0">
+            <a:spAutoFit/>
+          </a:bodyPr>
+          <a:lstStyle/>
+          <a:p>
+            <a:pPr algn="l">
+              <a:lnSpc>
+                <a:spcPts val="1875"/>
+              </a:lnSpc>
+              <a:spcAft>
+                <a:spcPts val="0"/>
+              </a:spcAft>
+            </a:pPr>
+            <a:r>
+              <a:rPr sz="1250" b="0" i="0">
+                <a:solidFill>
+                  <a:srgbClr val="1A2430"/>
+                </a:solidFill>
+                <a:latin typeface="Garamond"/>
+              </a:rPr>
+              <a:t>62</a:t>
+            </a:r>
+          </a:p>
+        </p:txBody>
+      </p:sp>
+      <p:sp>
+        <p:nvSpPr>
+          <p:cNvPr id="31" name="TextBox 30"/>
+          <p:cNvSpPr txBox="1"/>
+          <p:nvPr/>
+        </p:nvSpPr>
+        <p:spPr>
+          <a:xfrm>
+            <a:off x="1737360" y="4828031"/>
+            <a:ext cx="3017520" cy="384048"/>
+          </a:xfrm>
+          <a:prstGeom prst="rect">
+            <a:avLst/>
+          </a:prstGeom>
+          <a:noFill/>
+        </p:spPr>
+        <p:txBody>
+          <a:bodyPr wrap="square" lIns="0" rIns="0" tIns="0" bIns="0">
+            <a:spAutoFit/>
+          </a:bodyPr>
+          <a:lstStyle/>
+          <a:p>
+            <a:pPr algn="l">
+              <a:lnSpc>
+                <a:spcPts val="1875"/>
+              </a:lnSpc>
+              <a:spcAft>
+                <a:spcPts val="0"/>
+              </a:spcAft>
+            </a:pPr>
+            <a:r>
+              <a:rPr sz="1250" b="0" i="0">
+                <a:solidFill>
+                  <a:srgbClr val="1A2430"/>
+                </a:solidFill>
+                <a:latin typeface="Garamond"/>
+              </a:rPr>
+              <a:t>Elementary and middle school teachers</a:t>
+            </a:r>
+          </a:p>
+        </p:txBody>
+      </p:sp>
+      <p:sp>
+        <p:nvSpPr>
+          <p:cNvPr id="32" name="TextBox 31"/>
+          <p:cNvSpPr txBox="1"/>
+          <p:nvPr/>
+        </p:nvSpPr>
+        <p:spPr>
+          <a:xfrm>
+            <a:off x="4892040" y="4828031"/>
+            <a:ext cx="777240" cy="384048"/>
+          </a:xfrm>
+          <a:prstGeom prst="rect">
+            <a:avLst/>
+          </a:prstGeom>
+          <a:noFill/>
+        </p:spPr>
+        <p:txBody>
+          <a:bodyPr wrap="square" lIns="0" rIns="0" tIns="0" bIns="0">
+            <a:spAutoFit/>
+          </a:bodyPr>
+          <a:lstStyle/>
+          <a:p>
+            <a:pPr algn="l">
+              <a:lnSpc>
+                <a:spcPts val="1875"/>
+              </a:lnSpc>
+              <a:spcAft>
+                <a:spcPts val="0"/>
+              </a:spcAft>
+            </a:pPr>
+            <a:r>
+              <a:rPr sz="1250" b="0" i="0">
+                <a:solidFill>
+                  <a:srgbClr val="1A2430"/>
+                </a:solidFill>
+                <a:latin typeface="Garamond"/>
+              </a:rPr>
+              <a:t>26</a:t>
+            </a:r>
+          </a:p>
+        </p:txBody>
+      </p:sp>
+      <p:sp>
+        <p:nvSpPr>
+          <p:cNvPr id="33" name="TextBox 32"/>
+          <p:cNvSpPr txBox="1"/>
+          <p:nvPr/>
+        </p:nvSpPr>
+        <p:spPr>
+          <a:xfrm>
+            <a:off x="5806440" y="4828031"/>
+            <a:ext cx="1097280" cy="384048"/>
+          </a:xfrm>
+          <a:prstGeom prst="rect">
+            <a:avLst/>
+          </a:prstGeom>
+          <a:noFill/>
+        </p:spPr>
+        <p:txBody>
+          <a:bodyPr wrap="square" lIns="0" rIns="0" tIns="0" bIns="0">
+            <a:spAutoFit/>
+          </a:bodyPr>
+          <a:lstStyle/>
+          <a:p>
+            <a:pPr algn="l">
+              <a:lnSpc>
+                <a:spcPts val="1875"/>
+              </a:lnSpc>
+              <a:spcAft>
+                <a:spcPts val="0"/>
+              </a:spcAft>
+            </a:pPr>
+            <a:r>
+              <a:rPr sz="1250" b="0" i="0">
+                <a:solidFill>
+                  <a:srgbClr val="1A2430"/>
+                </a:solidFill>
+                <a:latin typeface="Garamond"/>
+              </a:rPr>
+              <a:t>$62,000</a:t>
+            </a:r>
+          </a:p>
+        </p:txBody>
+      </p:sp>
+      <p:sp>
+        <p:nvSpPr>
+          <p:cNvPr id="34" name="TextBox 33"/>
+          <p:cNvSpPr txBox="1"/>
+          <p:nvPr/>
+        </p:nvSpPr>
+        <p:spPr>
+          <a:xfrm>
+            <a:off x="7040880" y="4828031"/>
+            <a:ext cx="3017520" cy="384048"/>
+          </a:xfrm>
+          <a:prstGeom prst="rect">
+            <a:avLst/>
+          </a:prstGeom>
+          <a:noFill/>
+        </p:spPr>
+        <p:txBody>
+          <a:bodyPr wrap="square" lIns="0" rIns="0" tIns="0" bIns="0">
+            <a:spAutoFit/>
+          </a:bodyPr>
+          <a:lstStyle/>
+          <a:p>
+            <a:pPr algn="l">
+              <a:lnSpc>
+                <a:spcPts val="1875"/>
+              </a:lnSpc>
+              <a:spcAft>
+                <a:spcPts val="0"/>
+              </a:spcAft>
+            </a:pPr>
+            <a:r>
+              <a:rPr sz="1250" b="0" i="0">
+                <a:solidFill>
+                  <a:srgbClr val="1A2430"/>
+                </a:solidFill>
+                <a:latin typeface="Garamond"/>
+              </a:rPr>
+              <a:t>Not employed in March</a:t>
+            </a:r>
+          </a:p>
+        </p:txBody>
+      </p:sp>
+      <p:sp>
+        <p:nvSpPr>
+          <p:cNvPr id="35" name="TextBox 34"/>
+          <p:cNvSpPr txBox="1"/>
+          <p:nvPr/>
+        </p:nvSpPr>
+        <p:spPr>
+          <a:xfrm>
+            <a:off x="10195560" y="4828031"/>
+            <a:ext cx="1143000" cy="384048"/>
+          </a:xfrm>
+          <a:prstGeom prst="rect">
+            <a:avLst/>
+          </a:prstGeom>
+          <a:noFill/>
+        </p:spPr>
+        <p:txBody>
+          <a:bodyPr wrap="square" lIns="0" rIns="0" tIns="0" bIns="0">
+            <a:spAutoFit/>
+          </a:bodyPr>
+          <a:lstStyle/>
+          <a:p>
+            <a:pPr algn="l">
+              <a:lnSpc>
+                <a:spcPts val="1875"/>
+              </a:lnSpc>
+              <a:spcAft>
+                <a:spcPts val="0"/>
+              </a:spcAft>
+            </a:pPr>
+            <a:r>
+              <a:rPr sz="1250" b="1" i="0">
+                <a:solidFill>
+                  <a:srgbClr val="7B2530"/>
+                </a:solidFill>
+                <a:latin typeface="Garamond"/>
+              </a:rPr>
+              <a:t>leaver</a:t>
+            </a:r>
+          </a:p>
+        </p:txBody>
+      </p:sp>
+      <p:cxnSp>
+        <p:nvCxnSpPr>
+          <p:cNvPr id="36" name="Connector 35"/>
+          <p:cNvCxnSpPr/>
+          <p:nvPr/>
+        </p:nvCxnSpPr>
+        <p:spPr>
+          <a:xfrm>
+            <a:off x="822960" y="5321807"/>
+            <a:ext cx="10543032" cy="0"/>
+          </a:xfrm>
+          <a:prstGeom prst="line">
+            <a:avLst/>
+          </a:prstGeom>
+          <a:ln w="12700">
+            <a:solidFill>
+              <a:srgbClr val="1A2430"/>
+            </a:solidFill>
+          </a:ln>
+        </p:spPr>
+        <p:style>
+          <a:lnRef idx="2">
+            <a:schemeClr val="accent1"/>
+          </a:lnRef>
+          <a:fillRef idx="0">
+            <a:schemeClr val="accent1"/>
+          </a:fillRef>
+          <a:effectRef idx="1">
+            <a:schemeClr val="accent1"/>
+          </a:effectRef>
+          <a:fontRef idx="minor">
+            <a:schemeClr val="tx1"/>
+          </a:fontRef>
+        </p:style>
+      </p:cxnSp>
+      <p:sp>
+        <p:nvSpPr>
+          <p:cNvPr id="37" name="TextBox 36"/>
+          <p:cNvSpPr txBox="1"/>
+          <p:nvPr/>
+        </p:nvSpPr>
+        <p:spPr>
+          <a:xfrm>
+            <a:off x="822960" y="5522975"/>
+            <a:ext cx="10543032" cy="365760"/>
+          </a:xfrm>
+          <a:prstGeom prst="rect">
+            <a:avLst/>
+          </a:prstGeom>
+          <a:noFill/>
+        </p:spPr>
+        <p:txBody>
+          <a:bodyPr wrap="square" lIns="0" rIns="0" tIns="0" bIns="0">
+            <a:spAutoFit/>
+          </a:bodyPr>
+          <a:lstStyle/>
+          <a:p>
+            <a:pPr algn="l">
+              <a:lnSpc>
+                <a:spcPts val="1800"/>
+              </a:lnSpc>
+              <a:spcAft>
+                <a:spcPts val="0"/>
+              </a:spcAft>
+            </a:pPr>
+            <a:r>
+              <a:rPr sz="1200" b="0" i="1">
+                <a:solidFill>
+                  <a:srgbClr val="6B7480"/>
+                </a:solidFill>
+                <a:latin typeface="Garamond"/>
+              </a:rPr>
+              <a:t>Four records from the March 2025 supplement, as they enter the dataset.</a:t>
             </a:r>
           </a:p>
         </p:txBody>
@@ -8080,7 +8997,7 @@
         <p:spPr>
           <a:xfrm>
             <a:off x="777240" y="1691640"/>
-            <a:ext cx="10698480" cy="4754880"/>
+            <a:ext cx="10698480" cy="3657600"/>
           </a:xfrm>
           <a:prstGeom prst="rect">
             <a:avLst/>
@@ -8098,7 +9015,7 @@
                 <a:spcPts val="2550"/>
               </a:lnSpc>
               <a:spcAft>
-                <a:spcPts val="1400"/>
+                <a:spcPts val="1600"/>
               </a:spcAft>
             </a:pPr>
             <a:r>
@@ -8108,7 +9025,7 @@
                 </a:solidFill>
                 <a:latin typeface="Garamond"/>
               </a:rPr>
-              <a:t>The basic monthly interview measures current activity only: labor force status in the reference week and the occupation of the current job. It asks nothing about the past.</a:t>
+              <a:t>The basic monthly interview measures current activity only. Most months add a supplement on a rotating topic.</a:t>
             </a:r>
           </a:p>
           <a:p>
@@ -8117,7 +9034,7 @@
                 <a:spcPts val="2550"/>
               </a:lnSpc>
               <a:spcAft>
-                <a:spcPts val="1400"/>
+                <a:spcPts val="1600"/>
               </a:spcAft>
             </a:pPr>
             <a:r>
@@ -8127,26 +9044,7 @@
                 </a:solidFill>
                 <a:latin typeface="Garamond"/>
               </a:rPr>
-              <a:t>In most months a supplement is appended to the basic interview, a module on a rotating topic: school enrollment in October, voting in November, fertility, tobacco use.</a:t>
-            </a:r>
-          </a:p>
-          <a:p>
-            <a:pPr algn="just">
-              <a:lnSpc>
-                <a:spcPts val="2550"/>
-              </a:lnSpc>
-              <a:spcAft>
-                <a:spcPts val="1400"/>
-              </a:spcAft>
-            </a:pPr>
-            <a:r>
-              <a:rPr sz="1700" b="0" i="0">
-                <a:solidFill>
-                  <a:srgbClr val="1A2430"/>
-                </a:solidFill>
-                <a:latin typeface="Garamond"/>
-              </a:rPr>
-              <a:t>The March supplement, the Annual Social and Economic Supplement, is the largest and oldest. The sample is expanded to roughly 90,000 households, and every adult is asked about the entire previous calendar year: the longest job held, weeks worked, earnings, income, and benefits.</a:t>
+              <a:t>The March supplement expands the sample to roughly 90,000 households and asks every adult about the entire previous calendar year: longest job held, weeks worked, earnings.</a:t>
             </a:r>
           </a:p>
           <a:p>
@@ -8165,7 +9063,7 @@
                 </a:solidFill>
                 <a:latin typeface="Garamond"/>
               </a:rPr>
-              <a:t>The basic interview sees one month; only the March interview sees the whole preceding year. An annual leaving rate can therefore be measured in March, and in no other month.</a:t>
+              <a:t>An annual leaving rate can therefore be measured in March, and in no other month.</a:t>
             </a:r>
           </a:p>
         </p:txBody>
@@ -8274,7 +9172,7 @@
         <p:spPr>
           <a:xfrm>
             <a:off x="777240" y="1691640"/>
-            <a:ext cx="10698480" cy="4389120"/>
+            <a:ext cx="10698480" cy="2926080"/>
           </a:xfrm>
           <a:prstGeom prst="rect">
             <a:avLst/>
@@ -8292,7 +9190,7 @@
                 <a:spcPts val="2550"/>
               </a:lnSpc>
               <a:spcAft>
-                <a:spcPts val="1400"/>
+                <a:spcPts val="1600"/>
               </a:spcAft>
             </a:pPr>
             <a:r>
@@ -8302,26 +9200,7 @@
                 </a:solidFill>
                 <a:latin typeface="Garamond"/>
               </a:rPr>
-              <a:t>I pool every March supplement from 1998 to 2025 into a single file: five million individual records, 104,545 of them teachers, around 3,700 per year.</a:t>
-            </a:r>
-          </a:p>
-          <a:p>
-            <a:pPr algn="just">
-              <a:lnSpc>
-                <a:spcPts val="2550"/>
-              </a:lnSpc>
-              <a:spcAft>
-                <a:spcPts val="1400"/>
-              </a:spcAft>
-            </a:pPr>
-            <a:r>
-              <a:rPr sz="1700" b="0" i="0">
-                <a:solidFill>
-                  <a:srgbClr val="1A2430"/>
-                </a:solidFill>
-                <a:latin typeface="Garamond"/>
-              </a:rPr>
-              <a:t>Whoever taught as last year’s longest job, and no longer teaches at the March interview, has left the profession within the year.</a:t>
+              <a:t>I pool every March supplement from 1998 to 2025: five million records, 104,545 of them teachers.</a:t>
             </a:r>
           </a:p>
           <a:p>
@@ -8340,7 +9219,7 @@
                 </a:solidFill>
                 <a:latin typeface="Garamond"/>
               </a:rPr>
-              <a:t>Each record carries age, family structure, earnings, school sector, state, and pension coverage, so leaving can be related to what we observe about the teacher.</a:t>
+              <a:t>Whoever taught as last year’s longest job, and no longer teaches at the March interview, has left the profession within the year.</a:t>
             </a:r>
           </a:p>
         </p:txBody>
@@ -8449,7 +9328,7 @@
         <p:spPr>
           <a:xfrm>
             <a:off x="777240" y="1691640"/>
-            <a:ext cx="10698480" cy="1463040"/>
+            <a:ext cx="10698480" cy="731520"/>
           </a:xfrm>
           <a:prstGeom prst="rect">
             <a:avLst/>
@@ -8477,7 +9356,7 @@
                 </a:solidFill>
                 <a:latin typeface="Garamond"/>
               </a:rPr>
-              <a:t>The CPS carries no individual identifier across interviews: sampling follows addresses, not persons. Records are therefore linked across waves on household-level identifiers, and each candidate link is validated on demographic consistency, following Madrian and Lefgren (1999).</a:t>
+              <a:t>The CPS carries no individual identifier: records are linked on household identifiers and validated on demographics (Madrian and Lefgren, 1999).</a:t>
             </a:r>
           </a:p>
         </p:txBody>
@@ -8490,7 +9369,7 @@
         </p:nvCxnSpPr>
         <p:spPr>
           <a:xfrm>
-            <a:off x="822960" y="3063240"/>
+            <a:off x="822960" y="2788920"/>
             <a:ext cx="10543032" cy="0"/>
           </a:xfrm>
           <a:prstGeom prst="line">
@@ -8525,7 +9404,7 @@
         </p:nvSpPr>
         <p:spPr>
           <a:xfrm>
-            <a:off x="1005840" y="3246120"/>
+            <a:off x="1005840" y="2971800"/>
             <a:ext cx="4206240" cy="365760"/>
           </a:xfrm>
           <a:prstGeom prst="rect">
@@ -8567,7 +9446,7 @@
         </p:nvSpPr>
         <p:spPr>
           <a:xfrm>
-            <a:off x="6035040" y="3246120"/>
+            <a:off x="6035040" y="2971800"/>
             <a:ext cx="4937760" cy="365760"/>
           </a:xfrm>
           <a:prstGeom prst="rect">
@@ -8596,7 +9475,7 @@
                 </a:solidFill>
                 <a:latin typeface="Garamond"/>
               </a:rPr>
-              <a:t>Validation (demographic consistency)</a:t>
+              <a:t>Validation</a:t>
             </a:r>
           </a:p>
         </p:txBody>
@@ -8609,7 +9488,7 @@
         </p:nvSpPr>
         <p:spPr>
           <a:xfrm>
-            <a:off x="1005840" y="3730752"/>
+            <a:off x="1005840" y="3456432"/>
             <a:ext cx="4206240" cy="1463040"/>
           </a:xfrm>
           <a:prstGeom prst="rect">
@@ -8676,7 +9555,7 @@
                 </a:solidFill>
                 <a:latin typeface="Garamond"/>
               </a:rPr>
-              <a:t>Person line number within the household</a:t>
+              <a:t>Person line number</a:t>
             </a:r>
           </a:p>
         </p:txBody>
@@ -8689,7 +9568,7 @@
         </p:nvSpPr>
         <p:spPr>
           <a:xfrm>
-            <a:off x="6035040" y="3730752"/>
+            <a:off x="6035040" y="3456432"/>
             <a:ext cx="4937760" cy="1463040"/>
           </a:xfrm>
           <a:prstGeom prst="rect">
@@ -8718,7 +9597,7 @@
                 </a:solidFill>
                 <a:latin typeface="Garamond"/>
               </a:rPr>
-              <a:t>Sex, identical across interviews</a:t>
+              <a:t>Sex, identical</a:t>
             </a:r>
           </a:p>
           <a:p>
@@ -8737,7 +9616,7 @@
                 </a:solidFill>
                 <a:latin typeface="Garamond"/>
               </a:rPr>
-              <a:t>Race, identical across interviews</a:t>
+              <a:t>Race, identical</a:t>
             </a:r>
           </a:p>
           <a:p>
@@ -8769,7 +9648,7 @@
         </p:nvCxnSpPr>
         <p:spPr>
           <a:xfrm>
-            <a:off x="822960" y="5303520"/>
+            <a:off x="822960" y="5029200"/>
             <a:ext cx="10543032" cy="0"/>
           </a:xfrm>
           <a:prstGeom prst="line">
@@ -8804,8 +9683,8 @@
         </p:nvSpPr>
         <p:spPr>
           <a:xfrm>
-            <a:off x="777240" y="5577840"/>
-            <a:ext cx="10698480" cy="1097280"/>
+            <a:off x="777240" y="5303520"/>
+            <a:ext cx="10698480" cy="548640"/>
           </a:xfrm>
           <a:prstGeom prst="rect">
             <a:avLst/>
@@ -8833,7 +9712,7 @@
                 </a:solidFill>
                 <a:latin typeface="Garamond"/>
               </a:rPr>
-              <a:t>Validated links are obtained for 78 percent of teacher observations (74 percent of other college graduates). The loss is concentrated among movers, whose exit propensity exceeds that of non-movers; panel-based estimates are therefore lower bounds on mobility-related exit.</a:t>
+              <a:t>Validated links: 78 percent of teacher observations.</a:t>
             </a:r>
           </a:p>
         </p:txBody>
@@ -9160,10 +10039,12 @@
             <a:avLst/>
           </a:prstGeom>
           <a:solidFill>
-            <a:srgbClr val="7B2530"/>
+            <a:srgbClr val="FFFFFF"/>
           </a:solidFill>
-          <a:ln>
-            <a:noFill/>
+          <a:ln w="9525">
+            <a:solidFill>
+              <a:srgbClr val="C9CFD6"/>
+            </a:solidFill>
           </a:ln>
           <a:effectLst/>
         </p:spPr>
@@ -9182,19 +10063,10 @@
           </a:fontRef>
         </p:style>
         <p:txBody>
-          <a:bodyPr rtlCol="0" anchor="ctr" wrap="none"/>
+          <a:bodyPr rtlCol="0" anchor="ctr"/>
           <a:lstStyle/>
           <a:p>
             <a:pPr algn="ctr"/>
-            <a:r>
-              <a:rPr sz="1200" b="1">
-                <a:solidFill>
-                  <a:srgbClr val="FFFFFF"/>
-                </a:solidFill>
-                <a:latin typeface="Garamond"/>
-              </a:rPr>
-              <a:t>T</a:t>
-            </a:r>
           </a:p>
         </p:txBody>
       </p:sp>
@@ -9207,419 +10079,6 @@
         <p:spPr>
           <a:xfrm>
             <a:off x="4617720" y="1874519"/>
-            <a:ext cx="548640" cy="548640"/>
-          </a:xfrm>
-          <a:prstGeom prst="rect">
-            <a:avLst/>
-          </a:prstGeom>
-          <a:solidFill>
-            <a:srgbClr val="7B2530"/>
-          </a:solidFill>
-          <a:ln>
-            <a:noFill/>
-          </a:ln>
-          <a:effectLst/>
-        </p:spPr>
-        <p:style>
-          <a:lnRef idx="1">
-            <a:schemeClr val="accent1"/>
-          </a:lnRef>
-          <a:fillRef idx="3">
-            <a:schemeClr val="accent1"/>
-          </a:fillRef>
-          <a:effectRef idx="2">
-            <a:schemeClr val="accent1"/>
-          </a:effectRef>
-          <a:fontRef idx="minor">
-            <a:schemeClr val="lt1"/>
-          </a:fontRef>
-        </p:style>
-        <p:txBody>
-          <a:bodyPr rtlCol="0" anchor="ctr" wrap="none"/>
-          <a:lstStyle/>
-          <a:p>
-            <a:pPr algn="ctr"/>
-            <a:r>
-              <a:rPr sz="1200" b="1">
-                <a:solidFill>
-                  <a:srgbClr val="FFFFFF"/>
-                </a:solidFill>
-                <a:latin typeface="Garamond"/>
-              </a:rPr>
-              <a:t>T</a:t>
-            </a:r>
-          </a:p>
-        </p:txBody>
-      </p:sp>
-      <p:sp>
-        <p:nvSpPr>
-          <p:cNvPr id="10" name="Rectangle 9"/>
-          <p:cNvSpPr/>
-          <p:nvPr/>
-        </p:nvSpPr>
-        <p:spPr>
-          <a:xfrm>
-            <a:off x="5221224" y="1874519"/>
-            <a:ext cx="548640" cy="548640"/>
-          </a:xfrm>
-          <a:prstGeom prst="rect">
-            <a:avLst/>
-          </a:prstGeom>
-          <a:solidFill>
-            <a:srgbClr val="7B2530"/>
-          </a:solidFill>
-          <a:ln>
-            <a:noFill/>
-          </a:ln>
-          <a:effectLst/>
-        </p:spPr>
-        <p:style>
-          <a:lnRef idx="1">
-            <a:schemeClr val="accent1"/>
-          </a:lnRef>
-          <a:fillRef idx="3">
-            <a:schemeClr val="accent1"/>
-          </a:fillRef>
-          <a:effectRef idx="2">
-            <a:schemeClr val="accent1"/>
-          </a:effectRef>
-          <a:fontRef idx="minor">
-            <a:schemeClr val="lt1"/>
-          </a:fontRef>
-        </p:style>
-        <p:txBody>
-          <a:bodyPr rtlCol="0" anchor="ctr" wrap="none"/>
-          <a:lstStyle/>
-          <a:p>
-            <a:pPr algn="ctr"/>
-            <a:r>
-              <a:rPr sz="1200" b="1">
-                <a:solidFill>
-                  <a:srgbClr val="FFFFFF"/>
-                </a:solidFill>
-                <a:latin typeface="Garamond"/>
-              </a:rPr>
-              <a:t>T</a:t>
-            </a:r>
-          </a:p>
-        </p:txBody>
-      </p:sp>
-      <p:sp>
-        <p:nvSpPr>
-          <p:cNvPr id="11" name="Rectangle 10"/>
-          <p:cNvSpPr/>
-          <p:nvPr/>
-        </p:nvSpPr>
-        <p:spPr>
-          <a:xfrm>
-            <a:off x="5824728" y="1874519"/>
-            <a:ext cx="548640" cy="548640"/>
-          </a:xfrm>
-          <a:prstGeom prst="rect">
-            <a:avLst/>
-          </a:prstGeom>
-          <a:solidFill>
-            <a:srgbClr val="7B2530"/>
-          </a:solidFill>
-          <a:ln>
-            <a:noFill/>
-          </a:ln>
-          <a:effectLst/>
-        </p:spPr>
-        <p:style>
-          <a:lnRef idx="1">
-            <a:schemeClr val="accent1"/>
-          </a:lnRef>
-          <a:fillRef idx="3">
-            <a:schemeClr val="accent1"/>
-          </a:fillRef>
-          <a:effectRef idx="2">
-            <a:schemeClr val="accent1"/>
-          </a:effectRef>
-          <a:fontRef idx="minor">
-            <a:schemeClr val="lt1"/>
-          </a:fontRef>
-        </p:style>
-        <p:txBody>
-          <a:bodyPr rtlCol="0" anchor="ctr" wrap="none"/>
-          <a:lstStyle/>
-          <a:p>
-            <a:pPr algn="ctr"/>
-            <a:r>
-              <a:rPr sz="1200" b="1">
-                <a:solidFill>
-                  <a:srgbClr val="FFFFFF"/>
-                </a:solidFill>
-                <a:latin typeface="Garamond"/>
-              </a:rPr>
-              <a:t>T</a:t>
-            </a:r>
-          </a:p>
-        </p:txBody>
-      </p:sp>
-      <p:sp>
-        <p:nvSpPr>
-          <p:cNvPr id="12" name="TextBox 11"/>
-          <p:cNvSpPr txBox="1"/>
-          <p:nvPr/>
-        </p:nvSpPr>
-        <p:spPr>
-          <a:xfrm>
-            <a:off x="6748272" y="1984248"/>
-            <a:ext cx="4572000" cy="411480"/>
-          </a:xfrm>
-          <a:prstGeom prst="rect">
-            <a:avLst/>
-          </a:prstGeom>
-          <a:noFill/>
-        </p:spPr>
-        <p:txBody>
-          <a:bodyPr wrap="square" lIns="0" rIns="0" tIns="0" bIns="0">
-            <a:spAutoFit/>
-          </a:bodyPr>
-          <a:lstStyle/>
-          <a:p>
-            <a:pPr algn="l">
-              <a:lnSpc>
-                <a:spcPts val="2100"/>
-              </a:lnSpc>
-              <a:spcAft>
-                <a:spcPts val="0"/>
-              </a:spcAft>
-            </a:pPr>
-            <a:r>
-              <a:rPr sz="1400" b="1" i="0">
-                <a:solidFill>
-                  <a:srgbClr val="1F3864"/>
-                </a:solidFill>
-                <a:latin typeface="Garamond"/>
-              </a:rPr>
-              <a:t>stayer</a:t>
-            </a:r>
-          </a:p>
-        </p:txBody>
-      </p:sp>
-      <p:sp>
-        <p:nvSpPr>
-          <p:cNvPr id="13" name="Rectangle 12"/>
-          <p:cNvSpPr/>
-          <p:nvPr/>
-        </p:nvSpPr>
-        <p:spPr>
-          <a:xfrm>
-            <a:off x="822960" y="2807208"/>
-            <a:ext cx="548640" cy="548640"/>
-          </a:xfrm>
-          <a:prstGeom prst="rect">
-            <a:avLst/>
-          </a:prstGeom>
-          <a:solidFill>
-            <a:srgbClr val="1F3864"/>
-          </a:solidFill>
-          <a:ln>
-            <a:noFill/>
-          </a:ln>
-          <a:effectLst/>
-        </p:spPr>
-        <p:style>
-          <a:lnRef idx="1">
-            <a:schemeClr val="accent1"/>
-          </a:lnRef>
-          <a:fillRef idx="3">
-            <a:schemeClr val="accent1"/>
-          </a:fillRef>
-          <a:effectRef idx="2">
-            <a:schemeClr val="accent1"/>
-          </a:effectRef>
-          <a:fontRef idx="minor">
-            <a:schemeClr val="lt1"/>
-          </a:fontRef>
-        </p:style>
-        <p:txBody>
-          <a:bodyPr rtlCol="0" anchor="ctr" wrap="none"/>
-          <a:lstStyle/>
-          <a:p>
-            <a:pPr algn="ctr"/>
-            <a:r>
-              <a:rPr sz="1200" b="1">
-                <a:solidFill>
-                  <a:srgbClr val="FFFFFF"/>
-                </a:solidFill>
-                <a:latin typeface="Garamond"/>
-              </a:rPr>
-              <a:t>T</a:t>
-            </a:r>
-          </a:p>
-        </p:txBody>
-      </p:sp>
-      <p:sp>
-        <p:nvSpPr>
-          <p:cNvPr id="14" name="Rectangle 13"/>
-          <p:cNvSpPr/>
-          <p:nvPr/>
-        </p:nvSpPr>
-        <p:spPr>
-          <a:xfrm>
-            <a:off x="1426464" y="2807208"/>
-            <a:ext cx="548640" cy="548640"/>
-          </a:xfrm>
-          <a:prstGeom prst="rect">
-            <a:avLst/>
-          </a:prstGeom>
-          <a:solidFill>
-            <a:srgbClr val="1F3864"/>
-          </a:solidFill>
-          <a:ln>
-            <a:noFill/>
-          </a:ln>
-          <a:effectLst/>
-        </p:spPr>
-        <p:style>
-          <a:lnRef idx="1">
-            <a:schemeClr val="accent1"/>
-          </a:lnRef>
-          <a:fillRef idx="3">
-            <a:schemeClr val="accent1"/>
-          </a:fillRef>
-          <a:effectRef idx="2">
-            <a:schemeClr val="accent1"/>
-          </a:effectRef>
-          <a:fontRef idx="minor">
-            <a:schemeClr val="lt1"/>
-          </a:fontRef>
-        </p:style>
-        <p:txBody>
-          <a:bodyPr rtlCol="0" anchor="ctr" wrap="none"/>
-          <a:lstStyle/>
-          <a:p>
-            <a:pPr algn="ctr"/>
-            <a:r>
-              <a:rPr sz="1200" b="1">
-                <a:solidFill>
-                  <a:srgbClr val="FFFFFF"/>
-                </a:solidFill>
-                <a:latin typeface="Garamond"/>
-              </a:rPr>
-              <a:t>T</a:t>
-            </a:r>
-          </a:p>
-        </p:txBody>
-      </p:sp>
-      <p:sp>
-        <p:nvSpPr>
-          <p:cNvPr id="15" name="Rectangle 14"/>
-          <p:cNvSpPr/>
-          <p:nvPr/>
-        </p:nvSpPr>
-        <p:spPr>
-          <a:xfrm>
-            <a:off x="2029967" y="2807208"/>
-            <a:ext cx="548640" cy="548640"/>
-          </a:xfrm>
-          <a:prstGeom prst="rect">
-            <a:avLst/>
-          </a:prstGeom>
-          <a:solidFill>
-            <a:srgbClr val="1F3864"/>
-          </a:solidFill>
-          <a:ln>
-            <a:noFill/>
-          </a:ln>
-          <a:effectLst/>
-        </p:spPr>
-        <p:style>
-          <a:lnRef idx="1">
-            <a:schemeClr val="accent1"/>
-          </a:lnRef>
-          <a:fillRef idx="3">
-            <a:schemeClr val="accent1"/>
-          </a:fillRef>
-          <a:effectRef idx="2">
-            <a:schemeClr val="accent1"/>
-          </a:effectRef>
-          <a:fontRef idx="minor">
-            <a:schemeClr val="lt1"/>
-          </a:fontRef>
-        </p:style>
-        <p:txBody>
-          <a:bodyPr rtlCol="0" anchor="ctr" wrap="none"/>
-          <a:lstStyle/>
-          <a:p>
-            <a:pPr algn="ctr"/>
-            <a:r>
-              <a:rPr sz="1200" b="1">
-                <a:solidFill>
-                  <a:srgbClr val="FFFFFF"/>
-                </a:solidFill>
-                <a:latin typeface="Garamond"/>
-              </a:rPr>
-              <a:t>T</a:t>
-            </a:r>
-          </a:p>
-        </p:txBody>
-      </p:sp>
-      <p:sp>
-        <p:nvSpPr>
-          <p:cNvPr id="16" name="Rectangle 15"/>
-          <p:cNvSpPr/>
-          <p:nvPr/>
-        </p:nvSpPr>
-        <p:spPr>
-          <a:xfrm>
-            <a:off x="2633472" y="2807208"/>
-            <a:ext cx="548640" cy="548640"/>
-          </a:xfrm>
-          <a:prstGeom prst="rect">
-            <a:avLst/>
-          </a:prstGeom>
-          <a:solidFill>
-            <a:srgbClr val="1F3864"/>
-          </a:solidFill>
-          <a:ln>
-            <a:noFill/>
-          </a:ln>
-          <a:effectLst/>
-        </p:spPr>
-        <p:style>
-          <a:lnRef idx="1">
-            <a:schemeClr val="accent1"/>
-          </a:lnRef>
-          <a:fillRef idx="3">
-            <a:schemeClr val="accent1"/>
-          </a:fillRef>
-          <a:effectRef idx="2">
-            <a:schemeClr val="accent1"/>
-          </a:effectRef>
-          <a:fontRef idx="minor">
-            <a:schemeClr val="lt1"/>
-          </a:fontRef>
-        </p:style>
-        <p:txBody>
-          <a:bodyPr rtlCol="0" anchor="ctr" wrap="none"/>
-          <a:lstStyle/>
-          <a:p>
-            <a:pPr algn="ctr"/>
-            <a:r>
-              <a:rPr sz="1200" b="1">
-                <a:solidFill>
-                  <a:srgbClr val="FFFFFF"/>
-                </a:solidFill>
-                <a:latin typeface="Garamond"/>
-              </a:rPr>
-              <a:t>T</a:t>
-            </a:r>
-          </a:p>
-        </p:txBody>
-      </p:sp>
-      <p:sp>
-        <p:nvSpPr>
-          <p:cNvPr id="17" name="Rectangle 16"/>
-          <p:cNvSpPr/>
-          <p:nvPr/>
-        </p:nvSpPr>
-        <p:spPr>
-          <a:xfrm>
-            <a:off x="4014215" y="2807208"/>
             <a:ext cx="548640" cy="548640"/>
           </a:xfrm>
           <a:prstGeom prst="rect">
@@ -9659,13 +10118,13 @@
       </p:sp>
       <p:sp>
         <p:nvSpPr>
-          <p:cNvPr id="18" name="Rectangle 17"/>
+          <p:cNvPr id="10" name="Rectangle 9"/>
           <p:cNvSpPr/>
           <p:nvPr/>
         </p:nvSpPr>
         <p:spPr>
           <a:xfrm>
-            <a:off x="4617720" y="2807208"/>
+            <a:off x="5221224" y="1874519"/>
             <a:ext cx="548640" cy="548640"/>
           </a:xfrm>
           <a:prstGeom prst="rect">
@@ -9705,13 +10164,214 @@
       </p:sp>
       <p:sp>
         <p:nvSpPr>
-          <p:cNvPr id="19" name="Rectangle 18"/>
+          <p:cNvPr id="11" name="Rectangle 10"/>
           <p:cNvSpPr/>
           <p:nvPr/>
         </p:nvSpPr>
         <p:spPr>
           <a:xfrm>
-            <a:off x="5221224" y="2807208"/>
+            <a:off x="5824728" y="1874519"/>
+            <a:ext cx="548640" cy="548640"/>
+          </a:xfrm>
+          <a:prstGeom prst="rect">
+            <a:avLst/>
+          </a:prstGeom>
+          <a:solidFill>
+            <a:srgbClr val="7B2530"/>
+          </a:solidFill>
+          <a:ln>
+            <a:noFill/>
+          </a:ln>
+          <a:effectLst/>
+        </p:spPr>
+        <p:style>
+          <a:lnRef idx="1">
+            <a:schemeClr val="accent1"/>
+          </a:lnRef>
+          <a:fillRef idx="3">
+            <a:schemeClr val="accent1"/>
+          </a:fillRef>
+          <a:effectRef idx="2">
+            <a:schemeClr val="accent1"/>
+          </a:effectRef>
+          <a:fontRef idx="minor">
+            <a:schemeClr val="lt1"/>
+          </a:fontRef>
+        </p:style>
+        <p:txBody>
+          <a:bodyPr rtlCol="0" anchor="ctr" wrap="none"/>
+          <a:lstStyle/>
+          <a:p>
+            <a:pPr algn="ctr"/>
+            <a:r>
+              <a:rPr sz="1200" b="1">
+                <a:solidFill>
+                  <a:srgbClr val="FFFFFF"/>
+                </a:solidFill>
+                <a:latin typeface="Garamond"/>
+              </a:rPr>
+              <a:t>T</a:t>
+            </a:r>
+          </a:p>
+        </p:txBody>
+      </p:sp>
+      <p:sp>
+        <p:nvSpPr>
+          <p:cNvPr id="12" name="TextBox 11"/>
+          <p:cNvSpPr txBox="1"/>
+          <p:nvPr/>
+        </p:nvSpPr>
+        <p:spPr>
+          <a:xfrm>
+            <a:off x="6748272" y="1984248"/>
+            <a:ext cx="4572000" cy="411480"/>
+          </a:xfrm>
+          <a:prstGeom prst="rect">
+            <a:avLst/>
+          </a:prstGeom>
+          <a:noFill/>
+        </p:spPr>
+        <p:txBody>
+          <a:bodyPr wrap="square" lIns="0" rIns="0" tIns="0" bIns="0">
+            <a:spAutoFit/>
+          </a:bodyPr>
+          <a:lstStyle/>
+          <a:p>
+            <a:pPr algn="l">
+              <a:lnSpc>
+                <a:spcPts val="2100"/>
+              </a:lnSpc>
+              <a:spcAft>
+                <a:spcPts val="0"/>
+              </a:spcAft>
+            </a:pPr>
+            <a:r>
+              <a:rPr sz="1400" b="1" i="0">
+                <a:solidFill>
+                  <a:srgbClr val="1F3864"/>
+                </a:solidFill>
+                <a:latin typeface="Garamond"/>
+              </a:rPr>
+              <a:t>stayer</a:t>
+            </a:r>
+          </a:p>
+        </p:txBody>
+      </p:sp>
+      <p:sp>
+        <p:nvSpPr>
+          <p:cNvPr id="13" name="Rectangle 12"/>
+          <p:cNvSpPr/>
+          <p:nvPr/>
+        </p:nvSpPr>
+        <p:spPr>
+          <a:xfrm>
+            <a:off x="822960" y="2807208"/>
+            <a:ext cx="548640" cy="548640"/>
+          </a:xfrm>
+          <a:prstGeom prst="rect">
+            <a:avLst/>
+          </a:prstGeom>
+          <a:solidFill>
+            <a:srgbClr val="1F3864"/>
+          </a:solidFill>
+          <a:ln>
+            <a:noFill/>
+          </a:ln>
+          <a:effectLst/>
+        </p:spPr>
+        <p:style>
+          <a:lnRef idx="1">
+            <a:schemeClr val="accent1"/>
+          </a:lnRef>
+          <a:fillRef idx="3">
+            <a:schemeClr val="accent1"/>
+          </a:fillRef>
+          <a:effectRef idx="2">
+            <a:schemeClr val="accent1"/>
+          </a:effectRef>
+          <a:fontRef idx="minor">
+            <a:schemeClr val="lt1"/>
+          </a:fontRef>
+        </p:style>
+        <p:txBody>
+          <a:bodyPr rtlCol="0" anchor="ctr" wrap="none"/>
+          <a:lstStyle/>
+          <a:p>
+            <a:pPr algn="ctr"/>
+            <a:r>
+              <a:rPr sz="1200" b="1">
+                <a:solidFill>
+                  <a:srgbClr val="FFFFFF"/>
+                </a:solidFill>
+                <a:latin typeface="Garamond"/>
+              </a:rPr>
+              <a:t>T</a:t>
+            </a:r>
+          </a:p>
+        </p:txBody>
+      </p:sp>
+      <p:sp>
+        <p:nvSpPr>
+          <p:cNvPr id="14" name="Rectangle 13"/>
+          <p:cNvSpPr/>
+          <p:nvPr/>
+        </p:nvSpPr>
+        <p:spPr>
+          <a:xfrm>
+            <a:off x="1426464" y="2807208"/>
+            <a:ext cx="548640" cy="548640"/>
+          </a:xfrm>
+          <a:prstGeom prst="rect">
+            <a:avLst/>
+          </a:prstGeom>
+          <a:solidFill>
+            <a:srgbClr val="1F3864"/>
+          </a:solidFill>
+          <a:ln>
+            <a:noFill/>
+          </a:ln>
+          <a:effectLst/>
+        </p:spPr>
+        <p:style>
+          <a:lnRef idx="1">
+            <a:schemeClr val="accent1"/>
+          </a:lnRef>
+          <a:fillRef idx="3">
+            <a:schemeClr val="accent1"/>
+          </a:fillRef>
+          <a:effectRef idx="2">
+            <a:schemeClr val="accent1"/>
+          </a:effectRef>
+          <a:fontRef idx="minor">
+            <a:schemeClr val="lt1"/>
+          </a:fontRef>
+        </p:style>
+        <p:txBody>
+          <a:bodyPr rtlCol="0" anchor="ctr" wrap="none"/>
+          <a:lstStyle/>
+          <a:p>
+            <a:pPr algn="ctr"/>
+            <a:r>
+              <a:rPr sz="1200" b="1">
+                <a:solidFill>
+                  <a:srgbClr val="FFFFFF"/>
+                </a:solidFill>
+                <a:latin typeface="Garamond"/>
+              </a:rPr>
+              <a:t>T</a:t>
+            </a:r>
+          </a:p>
+        </p:txBody>
+      </p:sp>
+      <p:sp>
+        <p:nvSpPr>
+          <p:cNvPr id="15" name="Rectangle 14"/>
+          <p:cNvSpPr/>
+          <p:nvPr/>
+        </p:nvSpPr>
+        <p:spPr>
+          <a:xfrm>
+            <a:off x="2029967" y="2807208"/>
             <a:ext cx="548640" cy="548640"/>
           </a:xfrm>
           <a:prstGeom prst="rect">
@@ -9751,214 +10411,13 @@
       </p:sp>
       <p:sp>
         <p:nvSpPr>
-          <p:cNvPr id="20" name="Rectangle 19"/>
+          <p:cNvPr id="16" name="Rectangle 15"/>
           <p:cNvSpPr/>
           <p:nvPr/>
         </p:nvSpPr>
         <p:spPr>
           <a:xfrm>
-            <a:off x="5824728" y="2807208"/>
-            <a:ext cx="548640" cy="548640"/>
-          </a:xfrm>
-          <a:prstGeom prst="rect">
-            <a:avLst/>
-          </a:prstGeom>
-          <a:solidFill>
-            <a:srgbClr val="7B2530"/>
-          </a:solidFill>
-          <a:ln>
-            <a:noFill/>
-          </a:ln>
-          <a:effectLst/>
-        </p:spPr>
-        <p:style>
-          <a:lnRef idx="1">
-            <a:schemeClr val="accent1"/>
-          </a:lnRef>
-          <a:fillRef idx="3">
-            <a:schemeClr val="accent1"/>
-          </a:fillRef>
-          <a:effectRef idx="2">
-            <a:schemeClr val="accent1"/>
-          </a:effectRef>
-          <a:fontRef idx="minor">
-            <a:schemeClr val="lt1"/>
-          </a:fontRef>
-        </p:style>
-        <p:txBody>
-          <a:bodyPr rtlCol="0" anchor="ctr" wrap="none"/>
-          <a:lstStyle/>
-          <a:p>
-            <a:pPr algn="ctr"/>
-            <a:r>
-              <a:rPr sz="1200" b="1">
-                <a:solidFill>
-                  <a:srgbClr val="FFFFFF"/>
-                </a:solidFill>
-                <a:latin typeface="Garamond"/>
-              </a:rPr>
-              <a:t>T</a:t>
-            </a:r>
-          </a:p>
-        </p:txBody>
-      </p:sp>
-      <p:sp>
-        <p:nvSpPr>
-          <p:cNvPr id="21" name="TextBox 20"/>
-          <p:cNvSpPr txBox="1"/>
-          <p:nvPr/>
-        </p:nvSpPr>
-        <p:spPr>
-          <a:xfrm>
-            <a:off x="6748272" y="2916936"/>
-            <a:ext cx="4572000" cy="411480"/>
-          </a:xfrm>
-          <a:prstGeom prst="rect">
-            <a:avLst/>
-          </a:prstGeom>
-          <a:noFill/>
-        </p:spPr>
-        <p:txBody>
-          <a:bodyPr wrap="square" lIns="0" rIns="0" tIns="0" bIns="0">
-            <a:spAutoFit/>
-          </a:bodyPr>
-          <a:lstStyle/>
-          <a:p>
-            <a:pPr algn="l">
-              <a:lnSpc>
-                <a:spcPts val="2100"/>
-              </a:lnSpc>
-              <a:spcAft>
-                <a:spcPts val="0"/>
-              </a:spcAft>
-            </a:pPr>
-            <a:r>
-              <a:rPr sz="1400" b="1" i="0">
-                <a:solidFill>
-                  <a:srgbClr val="1F3864"/>
-                </a:solidFill>
-                <a:latin typeface="Garamond"/>
-              </a:rPr>
-              <a:t>stayer</a:t>
-            </a:r>
-          </a:p>
-        </p:txBody>
-      </p:sp>
-      <p:sp>
-        <p:nvSpPr>
-          <p:cNvPr id="22" name="Rectangle 21"/>
-          <p:cNvSpPr/>
-          <p:nvPr/>
-        </p:nvSpPr>
-        <p:spPr>
-          <a:xfrm>
-            <a:off x="822960" y="3739896"/>
-            <a:ext cx="548640" cy="548640"/>
-          </a:xfrm>
-          <a:prstGeom prst="rect">
-            <a:avLst/>
-          </a:prstGeom>
-          <a:solidFill>
-            <a:srgbClr val="1F3864"/>
-          </a:solidFill>
-          <a:ln>
-            <a:noFill/>
-          </a:ln>
-          <a:effectLst/>
-        </p:spPr>
-        <p:style>
-          <a:lnRef idx="1">
-            <a:schemeClr val="accent1"/>
-          </a:lnRef>
-          <a:fillRef idx="3">
-            <a:schemeClr val="accent1"/>
-          </a:fillRef>
-          <a:effectRef idx="2">
-            <a:schemeClr val="accent1"/>
-          </a:effectRef>
-          <a:fontRef idx="minor">
-            <a:schemeClr val="lt1"/>
-          </a:fontRef>
-        </p:style>
-        <p:txBody>
-          <a:bodyPr rtlCol="0" anchor="ctr" wrap="none"/>
-          <a:lstStyle/>
-          <a:p>
-            <a:pPr algn="ctr"/>
-            <a:r>
-              <a:rPr sz="1200" b="1">
-                <a:solidFill>
-                  <a:srgbClr val="FFFFFF"/>
-                </a:solidFill>
-                <a:latin typeface="Garamond"/>
-              </a:rPr>
-              <a:t>T</a:t>
-            </a:r>
-          </a:p>
-        </p:txBody>
-      </p:sp>
-      <p:sp>
-        <p:nvSpPr>
-          <p:cNvPr id="23" name="Rectangle 22"/>
-          <p:cNvSpPr/>
-          <p:nvPr/>
-        </p:nvSpPr>
-        <p:spPr>
-          <a:xfrm>
-            <a:off x="1426464" y="3739896"/>
-            <a:ext cx="548640" cy="548640"/>
-          </a:xfrm>
-          <a:prstGeom prst="rect">
-            <a:avLst/>
-          </a:prstGeom>
-          <a:solidFill>
-            <a:srgbClr val="1F3864"/>
-          </a:solidFill>
-          <a:ln>
-            <a:noFill/>
-          </a:ln>
-          <a:effectLst/>
-        </p:spPr>
-        <p:style>
-          <a:lnRef idx="1">
-            <a:schemeClr val="accent1"/>
-          </a:lnRef>
-          <a:fillRef idx="3">
-            <a:schemeClr val="accent1"/>
-          </a:fillRef>
-          <a:effectRef idx="2">
-            <a:schemeClr val="accent1"/>
-          </a:effectRef>
-          <a:fontRef idx="minor">
-            <a:schemeClr val="lt1"/>
-          </a:fontRef>
-        </p:style>
-        <p:txBody>
-          <a:bodyPr rtlCol="0" anchor="ctr" wrap="none"/>
-          <a:lstStyle/>
-          <a:p>
-            <a:pPr algn="ctr"/>
-            <a:r>
-              <a:rPr sz="1200" b="1">
-                <a:solidFill>
-                  <a:srgbClr val="FFFFFF"/>
-                </a:solidFill>
-                <a:latin typeface="Garamond"/>
-              </a:rPr>
-              <a:t>T</a:t>
-            </a:r>
-          </a:p>
-        </p:txBody>
-      </p:sp>
-      <p:sp>
-        <p:nvSpPr>
-          <p:cNvPr id="24" name="Rectangle 23"/>
-          <p:cNvSpPr/>
-          <p:nvPr/>
-        </p:nvSpPr>
-        <p:spPr>
-          <a:xfrm>
-            <a:off x="2029967" y="3739896"/>
+            <a:off x="2633472" y="2807208"/>
             <a:ext cx="548640" cy="548640"/>
           </a:xfrm>
           <a:prstGeom prst="rect">
@@ -9998,13 +10457,13 @@
       </p:sp>
       <p:sp>
         <p:nvSpPr>
-          <p:cNvPr id="25" name="Rectangle 24"/>
+          <p:cNvPr id="17" name="Rectangle 16"/>
           <p:cNvSpPr/>
           <p:nvPr/>
         </p:nvSpPr>
         <p:spPr>
           <a:xfrm>
-            <a:off x="2633472" y="3739896"/>
+            <a:off x="4014215" y="2807208"/>
             <a:ext cx="548640" cy="548640"/>
           </a:xfrm>
           <a:prstGeom prst="rect">
@@ -10044,13 +10503,13 @@
       </p:sp>
       <p:sp>
         <p:nvSpPr>
-          <p:cNvPr id="26" name="Rectangle 25"/>
+          <p:cNvPr id="18" name="Rectangle 17"/>
           <p:cNvSpPr/>
           <p:nvPr/>
         </p:nvSpPr>
         <p:spPr>
           <a:xfrm>
-            <a:off x="4014215" y="3739896"/>
+            <a:off x="4617720" y="2807208"/>
             <a:ext cx="548640" cy="548640"/>
           </a:xfrm>
           <a:prstGeom prst="rect">
@@ -10090,13 +10549,13 @@
       </p:sp>
       <p:sp>
         <p:nvSpPr>
-          <p:cNvPr id="27" name="Rectangle 26"/>
+          <p:cNvPr id="19" name="Rectangle 18"/>
           <p:cNvSpPr/>
           <p:nvPr/>
         </p:nvSpPr>
         <p:spPr>
           <a:xfrm>
-            <a:off x="4617720" y="3739896"/>
+            <a:off x="5221224" y="2807208"/>
             <a:ext cx="548640" cy="548640"/>
           </a:xfrm>
           <a:prstGeom prst="rect">
@@ -10136,13 +10595,13 @@
       </p:sp>
       <p:sp>
         <p:nvSpPr>
-          <p:cNvPr id="28" name="Rectangle 27"/>
+          <p:cNvPr id="20" name="Rectangle 19"/>
           <p:cNvSpPr/>
           <p:nvPr/>
         </p:nvSpPr>
         <p:spPr>
           <a:xfrm>
-            <a:off x="5221224" y="3739896"/>
+            <a:off x="5824728" y="2807208"/>
             <a:ext cx="548640" cy="548640"/>
           </a:xfrm>
           <a:prstGeom prst="rect">
@@ -10182,13 +10641,108 @@
       </p:sp>
       <p:sp>
         <p:nvSpPr>
-          <p:cNvPr id="29" name="Rectangle 28"/>
+          <p:cNvPr id="21" name="TextBox 20"/>
+          <p:cNvSpPr txBox="1"/>
+          <p:nvPr/>
+        </p:nvSpPr>
+        <p:spPr>
+          <a:xfrm>
+            <a:off x="6748272" y="2916936"/>
+            <a:ext cx="4572000" cy="411480"/>
+          </a:xfrm>
+          <a:prstGeom prst="rect">
+            <a:avLst/>
+          </a:prstGeom>
+          <a:noFill/>
+        </p:spPr>
+        <p:txBody>
+          <a:bodyPr wrap="square" lIns="0" rIns="0" tIns="0" bIns="0">
+            <a:spAutoFit/>
+          </a:bodyPr>
+          <a:lstStyle/>
+          <a:p>
+            <a:pPr algn="l">
+              <a:lnSpc>
+                <a:spcPts val="2100"/>
+              </a:lnSpc>
+              <a:spcAft>
+                <a:spcPts val="0"/>
+              </a:spcAft>
+            </a:pPr>
+            <a:r>
+              <a:rPr sz="1400" b="1" i="0">
+                <a:solidFill>
+                  <a:srgbClr val="7B2530"/>
+                </a:solidFill>
+                <a:latin typeface="Garamond"/>
+              </a:rPr>
+              <a:t>leaver</a:t>
+            </a:r>
+          </a:p>
+        </p:txBody>
+      </p:sp>
+      <p:sp>
+        <p:nvSpPr>
+          <p:cNvPr id="22" name="Rectangle 21"/>
           <p:cNvSpPr/>
           <p:nvPr/>
         </p:nvSpPr>
         <p:spPr>
           <a:xfrm>
-            <a:off x="5824728" y="3739896"/>
+            <a:off x="822960" y="3739896"/>
+            <a:ext cx="548640" cy="548640"/>
+          </a:xfrm>
+          <a:prstGeom prst="rect">
+            <a:avLst/>
+          </a:prstGeom>
+          <a:solidFill>
+            <a:srgbClr val="1F3864"/>
+          </a:solidFill>
+          <a:ln>
+            <a:noFill/>
+          </a:ln>
+          <a:effectLst/>
+        </p:spPr>
+        <p:style>
+          <a:lnRef idx="1">
+            <a:schemeClr val="accent1"/>
+          </a:lnRef>
+          <a:fillRef idx="3">
+            <a:schemeClr val="accent1"/>
+          </a:fillRef>
+          <a:effectRef idx="2">
+            <a:schemeClr val="accent1"/>
+          </a:effectRef>
+          <a:fontRef idx="minor">
+            <a:schemeClr val="lt1"/>
+          </a:fontRef>
+        </p:style>
+        <p:txBody>
+          <a:bodyPr rtlCol="0" anchor="ctr" wrap="none"/>
+          <a:lstStyle/>
+          <a:p>
+            <a:pPr algn="ctr"/>
+            <a:r>
+              <a:rPr sz="1200" b="1">
+                <a:solidFill>
+                  <a:srgbClr val="FFFFFF"/>
+                </a:solidFill>
+                <a:latin typeface="Garamond"/>
+              </a:rPr>
+              <a:t>T</a:t>
+            </a:r>
+          </a:p>
+        </p:txBody>
+      </p:sp>
+      <p:sp>
+        <p:nvSpPr>
+          <p:cNvPr id="23" name="Rectangle 22"/>
+          <p:cNvSpPr/>
+          <p:nvPr/>
+        </p:nvSpPr>
+        <p:spPr>
+          <a:xfrm>
+            <a:off x="1426464" y="3739896"/>
             <a:ext cx="548640" cy="548640"/>
           </a:xfrm>
           <a:prstGeom prst="rect">
@@ -10228,108 +10782,13 @@
       </p:sp>
       <p:sp>
         <p:nvSpPr>
-          <p:cNvPr id="30" name="TextBox 29"/>
-          <p:cNvSpPr txBox="1"/>
-          <p:nvPr/>
-        </p:nvSpPr>
-        <p:spPr>
-          <a:xfrm>
-            <a:off x="6748272" y="3849624"/>
-            <a:ext cx="4572000" cy="411480"/>
-          </a:xfrm>
-          <a:prstGeom prst="rect">
-            <a:avLst/>
-          </a:prstGeom>
-          <a:noFill/>
-        </p:spPr>
-        <p:txBody>
-          <a:bodyPr wrap="square" lIns="0" rIns="0" tIns="0" bIns="0">
-            <a:spAutoFit/>
-          </a:bodyPr>
-          <a:lstStyle/>
-          <a:p>
-            <a:pPr algn="l">
-              <a:lnSpc>
-                <a:spcPts val="2100"/>
-              </a:lnSpc>
-              <a:spcAft>
-                <a:spcPts val="0"/>
-              </a:spcAft>
-            </a:pPr>
-            <a:r>
-              <a:rPr sz="1400" b="1" i="0">
-                <a:solidFill>
-                  <a:srgbClr val="7B2530"/>
-                </a:solidFill>
-                <a:latin typeface="Garamond"/>
-              </a:rPr>
-              <a:t>leaver</a:t>
-            </a:r>
-          </a:p>
-        </p:txBody>
-      </p:sp>
-      <p:sp>
-        <p:nvSpPr>
-          <p:cNvPr id="31" name="Rectangle 30"/>
+          <p:cNvPr id="24" name="Rectangle 23"/>
           <p:cNvSpPr/>
           <p:nvPr/>
         </p:nvSpPr>
         <p:spPr>
           <a:xfrm>
-            <a:off x="822960" y="4672583"/>
-            <a:ext cx="548640" cy="548640"/>
-          </a:xfrm>
-          <a:prstGeom prst="rect">
-            <a:avLst/>
-          </a:prstGeom>
-          <a:solidFill>
-            <a:srgbClr val="1F3864"/>
-          </a:solidFill>
-          <a:ln>
-            <a:noFill/>
-          </a:ln>
-          <a:effectLst/>
-        </p:spPr>
-        <p:style>
-          <a:lnRef idx="1">
-            <a:schemeClr val="accent1"/>
-          </a:lnRef>
-          <a:fillRef idx="3">
-            <a:schemeClr val="accent1"/>
-          </a:fillRef>
-          <a:effectRef idx="2">
-            <a:schemeClr val="accent1"/>
-          </a:effectRef>
-          <a:fontRef idx="minor">
-            <a:schemeClr val="lt1"/>
-          </a:fontRef>
-        </p:style>
-        <p:txBody>
-          <a:bodyPr rtlCol="0" anchor="ctr" wrap="none"/>
-          <a:lstStyle/>
-          <a:p>
-            <a:pPr algn="ctr"/>
-            <a:r>
-              <a:rPr sz="1200" b="1">
-                <a:solidFill>
-                  <a:srgbClr val="FFFFFF"/>
-                </a:solidFill>
-                <a:latin typeface="Garamond"/>
-              </a:rPr>
-              <a:t>T</a:t>
-            </a:r>
-          </a:p>
-        </p:txBody>
-      </p:sp>
-      <p:sp>
-        <p:nvSpPr>
-          <p:cNvPr id="32" name="Rectangle 31"/>
-          <p:cNvSpPr/>
-          <p:nvPr/>
-        </p:nvSpPr>
-        <p:spPr>
-          <a:xfrm>
-            <a:off x="1426464" y="4672583"/>
+            <a:off x="2029967" y="3739896"/>
             <a:ext cx="548640" cy="548640"/>
           </a:xfrm>
           <a:prstGeom prst="rect">
@@ -10369,13 +10828,13 @@
       </p:sp>
       <p:sp>
         <p:nvSpPr>
-          <p:cNvPr id="33" name="Rectangle 32"/>
+          <p:cNvPr id="25" name="Rectangle 24"/>
           <p:cNvSpPr/>
           <p:nvPr/>
         </p:nvSpPr>
         <p:spPr>
           <a:xfrm>
-            <a:off x="2029967" y="4672583"/>
+            <a:off x="2633472" y="3739896"/>
             <a:ext cx="548640" cy="548640"/>
           </a:xfrm>
           <a:prstGeom prst="rect">
@@ -10415,13 +10874,13 @@
       </p:sp>
       <p:sp>
         <p:nvSpPr>
-          <p:cNvPr id="34" name="Rectangle 33"/>
+          <p:cNvPr id="26" name="Rectangle 25"/>
           <p:cNvSpPr/>
           <p:nvPr/>
         </p:nvSpPr>
         <p:spPr>
           <a:xfrm>
-            <a:off x="2633472" y="4672583"/>
+            <a:off x="4014215" y="3739896"/>
             <a:ext cx="548640" cy="548640"/>
           </a:xfrm>
           <a:prstGeom prst="rect">
@@ -10461,13 +10920,13 @@
       </p:sp>
       <p:sp>
         <p:nvSpPr>
-          <p:cNvPr id="35" name="Rectangle 34"/>
+          <p:cNvPr id="27" name="Rectangle 26"/>
           <p:cNvSpPr/>
           <p:nvPr/>
         </p:nvSpPr>
         <p:spPr>
           <a:xfrm>
-            <a:off x="4014215" y="4672583"/>
+            <a:off x="4617720" y="3739896"/>
             <a:ext cx="548640" cy="548640"/>
           </a:xfrm>
           <a:prstGeom prst="rect">
@@ -10507,13 +10966,13 @@
       </p:sp>
       <p:sp>
         <p:nvSpPr>
-          <p:cNvPr id="36" name="Rectangle 35"/>
+          <p:cNvPr id="28" name="Rectangle 27"/>
           <p:cNvSpPr/>
           <p:nvPr/>
         </p:nvSpPr>
         <p:spPr>
           <a:xfrm>
-            <a:off x="4617720" y="4672583"/>
+            <a:off x="5221224" y="3739896"/>
             <a:ext cx="548640" cy="548640"/>
           </a:xfrm>
           <a:prstGeom prst="rect">
@@ -10553,13 +11012,13 @@
       </p:sp>
       <p:sp>
         <p:nvSpPr>
-          <p:cNvPr id="37" name="Rectangle 36"/>
+          <p:cNvPr id="29" name="Rectangle 28"/>
           <p:cNvSpPr/>
           <p:nvPr/>
         </p:nvSpPr>
         <p:spPr>
           <a:xfrm>
-            <a:off x="5221224" y="4672583"/>
+            <a:off x="5824728" y="3739896"/>
             <a:ext cx="548640" cy="548640"/>
           </a:xfrm>
           <a:prstGeom prst="rect">
@@ -10599,59 +11058,13 @@
       </p:sp>
       <p:sp>
         <p:nvSpPr>
-          <p:cNvPr id="38" name="Rectangle 37"/>
-          <p:cNvSpPr/>
-          <p:nvPr/>
-        </p:nvSpPr>
-        <p:spPr>
-          <a:xfrm>
-            <a:off x="5824728" y="4672583"/>
-            <a:ext cx="548640" cy="548640"/>
-          </a:xfrm>
-          <a:prstGeom prst="rect">
-            <a:avLst/>
-          </a:prstGeom>
-          <a:solidFill>
-            <a:srgbClr val="FFFFFF"/>
-          </a:solidFill>
-          <a:ln w="9525">
-            <a:solidFill>
-              <a:srgbClr val="C9CFD6"/>
-            </a:solidFill>
-          </a:ln>
-          <a:effectLst/>
-        </p:spPr>
-        <p:style>
-          <a:lnRef idx="1">
-            <a:schemeClr val="accent1"/>
-          </a:lnRef>
-          <a:fillRef idx="3">
-            <a:schemeClr val="accent1"/>
-          </a:fillRef>
-          <a:effectRef idx="2">
-            <a:schemeClr val="accent1"/>
-          </a:effectRef>
-          <a:fontRef idx="minor">
-            <a:schemeClr val="lt1"/>
-          </a:fontRef>
-        </p:style>
-        <p:txBody>
-          <a:bodyPr rtlCol="0" anchor="ctr"/>
-          <a:lstStyle/>
-          <a:p>
-            <a:pPr algn="ctr"/>
-          </a:p>
-        </p:txBody>
-      </p:sp>
-      <p:sp>
-        <p:nvSpPr>
-          <p:cNvPr id="39" name="TextBox 38"/>
+          <p:cNvPr id="30" name="TextBox 29"/>
           <p:cNvSpPr txBox="1"/>
           <p:nvPr/>
         </p:nvSpPr>
         <p:spPr>
           <a:xfrm>
-            <a:off x="6748272" y="4782312"/>
+            <a:off x="6748272" y="3849624"/>
             <a:ext cx="4572000" cy="411480"/>
           </a:xfrm>
           <a:prstGeom prst="rect">
@@ -10680,20 +11093,20 @@
                 </a:solidFill>
                 <a:latin typeface="Garamond"/>
               </a:rPr>
-              <a:t>excluded: a single year-1 observation</a:t>
-            </a:r>
-          </a:p>
-        </p:txBody>
-      </p:sp>
-      <p:sp>
-        <p:nvSpPr>
-          <p:cNvPr id="40" name="TextBox 39"/>
+              <a:t>excluded</a:t>
+            </a:r>
+          </a:p>
+        </p:txBody>
+      </p:sp>
+      <p:sp>
+        <p:nvSpPr>
+          <p:cNvPr id="31" name="TextBox 30"/>
           <p:cNvSpPr txBox="1"/>
           <p:nvPr/>
         </p:nvSpPr>
         <p:spPr>
           <a:xfrm>
-            <a:off x="822960" y="5678423"/>
+            <a:off x="822960" y="4745736"/>
             <a:ext cx="4572000" cy="320040"/>
           </a:xfrm>
           <a:prstGeom prst="rect">
@@ -10729,13 +11142,13 @@
       </p:sp>
       <p:sp>
         <p:nvSpPr>
-          <p:cNvPr id="41" name="TextBox 40"/>
+          <p:cNvPr id="32" name="TextBox 31"/>
           <p:cNvSpPr txBox="1"/>
           <p:nvPr/>
         </p:nvSpPr>
         <p:spPr>
           <a:xfrm>
-            <a:off x="5806440" y="5678423"/>
+            <a:off x="5806440" y="4745736"/>
             <a:ext cx="4572000" cy="320040"/>
           </a:xfrm>
           <a:prstGeom prst="rect">
@@ -10771,13 +11184,13 @@
       </p:sp>
       <p:sp>
         <p:nvSpPr>
-          <p:cNvPr id="42" name="TextBox 41"/>
+          <p:cNvPr id="33" name="TextBox 32"/>
           <p:cNvSpPr txBox="1"/>
           <p:nvPr/>
         </p:nvSpPr>
         <p:spPr>
           <a:xfrm>
-            <a:off x="822960" y="6080759"/>
+            <a:off x="822960" y="5148071"/>
             <a:ext cx="10515600" cy="365760"/>
           </a:xfrm>
           <a:prstGeom prst="rect">
@@ -10806,7 +11219,7 @@
                 </a:solidFill>
                 <a:latin typeface="Garamond"/>
               </a:rPr>
-              <a:t>Filled cells denote interviews in which the individual is observed teaching; bordered cells, interviews without teaching.</a:t>
+              <a:t>Filled cells: observed teaching.</a:t>
             </a:r>
           </a:p>
         </p:txBody>
@@ -12052,7 +12465,7 @@
                 </a:solidFill>
                 <a:latin typeface="Garamond"/>
               </a:rPr>
-              <a:t>employed with a teaching occupation, holding a bachelor’s degree, in at least two year-1 interviews</a:t>
+              <a:t>teaching, with a bachelor’s degree, in at least two year-1 interviews</a:t>
             </a:r>
           </a:p>
         </p:txBody>
@@ -12136,7 +12549,7 @@
                 </a:solidFill>
                 <a:latin typeface="Garamond"/>
               </a:rPr>
-              <a:t>observed teaching in at least one year-2 interview</a:t>
+              <a:t>teaching in at least one year-2 interview</a:t>
             </a:r>
           </a:p>
         </p:txBody>
@@ -12220,7 +12633,7 @@
                 </a:solidFill>
                 <a:latin typeface="Garamond"/>
               </a:rPr>
-              <a:t>never observed teaching in year 2, given two or more year-2 interviews, one outside June–August</a:t>
+              <a:t>never teaching in year 2, given two or more interviews, one outside the summer</a:t>
             </a:r>
           </a:p>
         </p:txBody>
@@ -12388,7 +12801,7 @@
         <p:spPr>
           <a:xfrm>
             <a:off x="1005840" y="4663440"/>
-            <a:ext cx="2834640" cy="329184"/>
+            <a:ext cx="5486400" cy="329184"/>
           </a:xfrm>
           <a:prstGeom prst="rect">
             <a:avLst/>
@@ -12403,14 +12816,14 @@
           <a:p>
             <a:pPr algn="l">
               <a:lnSpc>
-                <a:spcPts val="1725"/>
+                <a:spcPts val="1800"/>
               </a:lnSpc>
               <a:spcAft>
                 <a:spcPts val="0"/>
               </a:spcAft>
             </a:pPr>
             <a:r>
-              <a:rPr sz="1150" b="1" i="0">
+              <a:rPr sz="1200" b="0" i="0">
                 <a:solidFill>
                   <a:srgbClr val="1A2430"/>
                 </a:solidFill>
@@ -12429,8 +12842,8 @@
         </p:nvSpPr>
         <p:spPr>
           <a:xfrm>
-            <a:off x="3977639" y="4663440"/>
-            <a:ext cx="5852160" cy="329184"/>
+            <a:off x="10058400" y="4663440"/>
+            <a:ext cx="1097280" cy="329184"/>
           </a:xfrm>
           <a:prstGeom prst="rect">
             <a:avLst/>
@@ -12445,20 +12858,20 @@
           <a:p>
             <a:pPr algn="l">
               <a:lnSpc>
-                <a:spcPts val="1725"/>
+                <a:spcPts val="1800"/>
               </a:lnSpc>
               <a:spcAft>
                 <a:spcPts val="0"/>
               </a:spcAft>
             </a:pPr>
             <a:r>
-              <a:rPr sz="1150" b="0" i="0">
+              <a:rPr sz="1200" b="1" i="0">
                 <a:solidFill>
                   <a:srgbClr val="1A2430"/>
                 </a:solidFill>
                 <a:latin typeface="Garamond"/>
               </a:rPr>
-              <a:t>one classification per individual</a:t>
+              <a:t>12.9</a:t>
             </a:r>
           </a:p>
         </p:txBody>
@@ -12471,8 +12884,8 @@
         </p:nvSpPr>
         <p:spPr>
           <a:xfrm>
-            <a:off x="10058400" y="4663440"/>
-            <a:ext cx="1097280" cy="329184"/>
+            <a:off x="1005840" y="4992624"/>
+            <a:ext cx="5486400" cy="329184"/>
           </a:xfrm>
           <a:prstGeom prst="rect">
             <a:avLst/>
@@ -12487,20 +12900,20 @@
           <a:p>
             <a:pPr algn="l">
               <a:lnSpc>
-                <a:spcPts val="1725"/>
+                <a:spcPts val="1800"/>
               </a:lnSpc>
               <a:spcAft>
                 <a:spcPts val="0"/>
               </a:spcAft>
             </a:pPr>
             <a:r>
-              <a:rPr sz="1150" b="1" i="0">
+              <a:rPr sz="1200" b="0" i="0">
                 <a:solidFill>
                   <a:srgbClr val="1A2430"/>
                 </a:solidFill>
                 <a:latin typeface="Garamond"/>
               </a:rPr>
-              <a:t>12.9</a:t>
+              <a:t>Retrospective annual measure</a:t>
             </a:r>
           </a:p>
         </p:txBody>
@@ -12513,8 +12926,8 @@
         </p:nvSpPr>
         <p:spPr>
           <a:xfrm>
-            <a:off x="1005840" y="4992624"/>
-            <a:ext cx="2834640" cy="329184"/>
+            <a:off x="10058400" y="4992624"/>
+            <a:ext cx="1097280" cy="329184"/>
           </a:xfrm>
           <a:prstGeom prst="rect">
             <a:avLst/>
@@ -12529,20 +12942,20 @@
           <a:p>
             <a:pPr algn="l">
               <a:lnSpc>
-                <a:spcPts val="1725"/>
+                <a:spcPts val="1800"/>
               </a:lnSpc>
               <a:spcAft>
                 <a:spcPts val="0"/>
               </a:spcAft>
             </a:pPr>
             <a:r>
-              <a:rPr sz="1150" b="1" i="0">
+              <a:rPr sz="1200" b="1" i="0">
                 <a:solidFill>
                   <a:srgbClr val="1A2430"/>
                 </a:solidFill>
                 <a:latin typeface="Garamond"/>
               </a:rPr>
-              <a:t>Retrospective annual measure</a:t>
+              <a:t>7.1</a:t>
             </a:r>
           </a:p>
         </p:txBody>
@@ -12555,8 +12968,8 @@
         </p:nvSpPr>
         <p:spPr>
           <a:xfrm>
-            <a:off x="3977639" y="4992624"/>
-            <a:ext cx="5852160" cy="329184"/>
+            <a:off x="1005840" y="5321808"/>
+            <a:ext cx="5486400" cy="329184"/>
           </a:xfrm>
           <a:prstGeom prst="rect">
             <a:avLst/>
@@ -12571,20 +12984,20 @@
           <a:p>
             <a:pPr algn="l">
               <a:lnSpc>
-                <a:spcPts val="1725"/>
+                <a:spcPts val="1800"/>
               </a:lnSpc>
               <a:spcAft>
                 <a:spcPts val="0"/>
               </a:spcAft>
             </a:pPr>
             <a:r>
-              <a:rPr sz="1150" b="0" i="0">
+              <a:rPr sz="1200" b="0" i="0">
                 <a:solidFill>
                   <a:srgbClr val="1A2430"/>
                 </a:solidFill>
                 <a:latin typeface="Garamond"/>
               </a:rPr>
-              <a:t>longest job of the previous year no longer held at the March interview</a:t>
+              <a:t>Occupation-pair measure</a:t>
             </a:r>
           </a:p>
         </p:txBody>
@@ -12597,7 +13010,7 @@
         </p:nvSpPr>
         <p:spPr>
           <a:xfrm>
-            <a:off x="10058400" y="4992624"/>
+            <a:off x="10058400" y="5321808"/>
             <a:ext cx="1097280" cy="329184"/>
           </a:xfrm>
           <a:prstGeom prst="rect">
@@ -12613,20 +13026,20 @@
           <a:p>
             <a:pPr algn="l">
               <a:lnSpc>
-                <a:spcPts val="1725"/>
+                <a:spcPts val="1800"/>
               </a:lnSpc>
               <a:spcAft>
                 <a:spcPts val="0"/>
               </a:spcAft>
             </a:pPr>
             <a:r>
-              <a:rPr sz="1150" b="1" i="0">
+              <a:rPr sz="1200" b="1" i="0">
                 <a:solidFill>
                   <a:srgbClr val="1A2430"/>
                 </a:solidFill>
                 <a:latin typeface="Garamond"/>
               </a:rPr>
-              <a:t>7.1</a:t>
+              <a:t>5.0</a:t>
             </a:r>
           </a:p>
         </p:txBody>
@@ -12639,8 +13052,8 @@
         </p:nvSpPr>
         <p:spPr>
           <a:xfrm>
-            <a:off x="1005840" y="5321808"/>
-            <a:ext cx="2834640" cy="329184"/>
+            <a:off x="1005840" y="5650992"/>
+            <a:ext cx="5486400" cy="329184"/>
           </a:xfrm>
           <a:prstGeom prst="rect">
             <a:avLst/>
@@ -12655,20 +13068,20 @@
           <a:p>
             <a:pPr algn="l">
               <a:lnSpc>
-                <a:spcPts val="1725"/>
+                <a:spcPts val="1800"/>
               </a:lnSpc>
               <a:spcAft>
                 <a:spcPts val="0"/>
               </a:spcAft>
             </a:pPr>
             <a:r>
-              <a:rPr sz="1150" b="1" i="0">
+              <a:rPr sz="1200" b="0" i="0">
                 <a:solidFill>
                   <a:srgbClr val="1A2430"/>
                 </a:solidFill>
                 <a:latin typeface="Garamond"/>
               </a:rPr>
-              <a:t>Occupation-pair measure</a:t>
+              <a:t>Month-pair measure</a:t>
             </a:r>
           </a:p>
         </p:txBody>
@@ -12681,8 +13094,8 @@
         </p:nvSpPr>
         <p:spPr>
           <a:xfrm>
-            <a:off x="3977639" y="5321808"/>
-            <a:ext cx="5852160" cy="329184"/>
+            <a:off x="10058400" y="5650992"/>
+            <a:ext cx="1097280" cy="329184"/>
           </a:xfrm>
           <a:prstGeom prst="rect">
             <a:avLst/>
@@ -12697,20 +13110,20 @@
           <a:p>
             <a:pPr algn="l">
               <a:lnSpc>
-                <a:spcPts val="1725"/>
+                <a:spcPts val="1800"/>
               </a:lnSpc>
               <a:spcAft>
                 <a:spcPts val="0"/>
               </a:spcAft>
             </a:pPr>
             <a:r>
-              <a:rPr sz="1150" b="0" i="0">
+              <a:rPr sz="1200" b="1" i="0">
                 <a:solidFill>
                   <a:srgbClr val="1A2430"/>
                 </a:solidFill>
                 <a:latin typeface="Garamond"/>
               </a:rPr>
-              <a:t>previous-year and current occupation codes compared directly</a:t>
+              <a:t>16.0</a:t>
             </a:r>
           </a:p>
         </p:txBody>
@@ -12723,8 +13136,8 @@
         </p:nvSpPr>
         <p:spPr>
           <a:xfrm>
-            <a:off x="10058400" y="5321808"/>
-            <a:ext cx="1097280" cy="329184"/>
+            <a:off x="1005840" y="5980176"/>
+            <a:ext cx="5486400" cy="329184"/>
           </a:xfrm>
           <a:prstGeom prst="rect">
             <a:avLst/>
@@ -12739,20 +13152,20 @@
           <a:p>
             <a:pPr algn="l">
               <a:lnSpc>
-                <a:spcPts val="1725"/>
+                <a:spcPts val="1800"/>
               </a:lnSpc>
               <a:spcAft>
                 <a:spcPts val="0"/>
               </a:spcAft>
             </a:pPr>
             <a:r>
-              <a:rPr sz="1150" b="1" i="0">
+              <a:rPr sz="1200" b="0" i="0">
                 <a:solidFill>
                   <a:srgbClr val="1A2430"/>
                 </a:solidFill>
                 <a:latin typeface="Garamond"/>
               </a:rPr>
-              <a:t>5.0</a:t>
+              <a:t>Any-sighting measure</a:t>
             </a:r>
           </a:p>
         </p:txBody>
@@ -12765,8 +13178,8 @@
         </p:nvSpPr>
         <p:spPr>
           <a:xfrm>
-            <a:off x="1005840" y="5650992"/>
-            <a:ext cx="2834640" cy="329184"/>
+            <a:off x="10058400" y="5980176"/>
+            <a:ext cx="1097280" cy="329184"/>
           </a:xfrm>
           <a:prstGeom prst="rect">
             <a:avLst/>
@@ -12781,20 +13194,20 @@
           <a:p>
             <a:pPr algn="l">
               <a:lnSpc>
-                <a:spcPts val="1725"/>
+                <a:spcPts val="1800"/>
               </a:lnSpc>
               <a:spcAft>
                 <a:spcPts val="0"/>
               </a:spcAft>
             </a:pPr>
             <a:r>
-              <a:rPr sz="1150" b="1" i="0">
+              <a:rPr sz="1200" b="1" i="0">
                 <a:solidFill>
                   <a:srgbClr val="1A2430"/>
                 </a:solidFill>
                 <a:latin typeface="Garamond"/>
               </a:rPr>
-              <a:t>Month-pair measure</a:t>
+              <a:t>19.4</a:t>
             </a:r>
           </a:p>
         </p:txBody>
@@ -12807,8 +13220,8 @@
         </p:nvSpPr>
         <p:spPr>
           <a:xfrm>
-            <a:off x="3977639" y="5650992"/>
-            <a:ext cx="5852160" cy="329184"/>
+            <a:off x="1005840" y="6309360"/>
+            <a:ext cx="5486400" cy="329184"/>
           </a:xfrm>
           <a:prstGeom prst="rect">
             <a:avLst/>
@@ -12823,20 +13236,20 @@
           <a:p>
             <a:pPr algn="l">
               <a:lnSpc>
-                <a:spcPts val="1725"/>
+                <a:spcPts val="1800"/>
               </a:lnSpc>
               <a:spcAft>
                 <a:spcPts val="0"/>
               </a:spcAft>
             </a:pPr>
             <a:r>
-              <a:rPr sz="1150" b="0" i="0">
+              <a:rPr sz="1200" b="0" i="0">
                 <a:solidFill>
                   <a:srgbClr val="1A2430"/>
                 </a:solidFill>
                 <a:latin typeface="Garamond"/>
               </a:rPr>
-              <a:t>each teaching month matched to its interview twelve months ahead</a:t>
+              <a:t>NCES Teacher Follow-up Survey</a:t>
             </a:r>
           </a:p>
         </p:txBody>
@@ -12849,7 +13262,7 @@
         </p:nvSpPr>
         <p:spPr>
           <a:xfrm>
-            <a:off x="10058400" y="5650992"/>
+            <a:off x="10058400" y="6309360"/>
             <a:ext cx="1097280" cy="329184"/>
           </a:xfrm>
           <a:prstGeom prst="rect">
@@ -12865,266 +13278,14 @@
           <a:p>
             <a:pPr algn="l">
               <a:lnSpc>
-                <a:spcPts val="1725"/>
+                <a:spcPts val="1800"/>
               </a:lnSpc>
               <a:spcAft>
                 <a:spcPts val="0"/>
               </a:spcAft>
             </a:pPr>
             <a:r>
-              <a:rPr sz="1150" b="1" i="0">
-                <a:solidFill>
-                  <a:srgbClr val="1A2430"/>
-                </a:solidFill>
-                <a:latin typeface="Garamond"/>
-              </a:rPr>
-              <a:t>16.0</a:t>
-            </a:r>
-          </a:p>
-        </p:txBody>
-      </p:sp>
-      <p:sp>
-        <p:nvSpPr>
-          <p:cNvPr id="47" name="TextBox 46"/>
-          <p:cNvSpPr txBox="1"/>
-          <p:nvPr/>
-        </p:nvSpPr>
-        <p:spPr>
-          <a:xfrm>
-            <a:off x="1005840" y="5980176"/>
-            <a:ext cx="2834640" cy="329184"/>
-          </a:xfrm>
-          <a:prstGeom prst="rect">
-            <a:avLst/>
-          </a:prstGeom>
-          <a:noFill/>
-        </p:spPr>
-        <p:txBody>
-          <a:bodyPr wrap="square" lIns="0" rIns="0" tIns="0" bIns="0">
-            <a:spAutoFit/>
-          </a:bodyPr>
-          <a:lstStyle/>
-          <a:p>
-            <a:pPr algn="l">
-              <a:lnSpc>
-                <a:spcPts val="1725"/>
-              </a:lnSpc>
-              <a:spcAft>
-                <a:spcPts val="0"/>
-              </a:spcAft>
-            </a:pPr>
-            <a:r>
-              <a:rPr sz="1150" b="1" i="0">
-                <a:solidFill>
-                  <a:srgbClr val="1A2430"/>
-                </a:solidFill>
-                <a:latin typeface="Garamond"/>
-              </a:rPr>
-              <a:t>Any-sighting measure</a:t>
-            </a:r>
-          </a:p>
-        </p:txBody>
-      </p:sp>
-      <p:sp>
-        <p:nvSpPr>
-          <p:cNvPr id="48" name="TextBox 47"/>
-          <p:cNvSpPr txBox="1"/>
-          <p:nvPr/>
-        </p:nvSpPr>
-        <p:spPr>
-          <a:xfrm>
-            <a:off x="3977639" y="5980176"/>
-            <a:ext cx="5852160" cy="329184"/>
-          </a:xfrm>
-          <a:prstGeom prst="rect">
-            <a:avLst/>
-          </a:prstGeom>
-          <a:noFill/>
-        </p:spPr>
-        <p:txBody>
-          <a:bodyPr wrap="square" lIns="0" rIns="0" tIns="0" bIns="0">
-            <a:spAutoFit/>
-          </a:bodyPr>
-          <a:lstStyle/>
-          <a:p>
-            <a:pPr algn="l">
-              <a:lnSpc>
-                <a:spcPts val="1725"/>
-              </a:lnSpc>
-              <a:spcAft>
-                <a:spcPts val="0"/>
-              </a:spcAft>
-            </a:pPr>
-            <a:r>
-              <a:rPr sz="1150" b="0" i="0">
-                <a:solidFill>
-                  <a:srgbClr val="1A2430"/>
-                </a:solidFill>
-                <a:latin typeface="Garamond"/>
-              </a:rPr>
-              <a:t>any individual observed teaching once in year 1 enters the denominator</a:t>
-            </a:r>
-          </a:p>
-        </p:txBody>
-      </p:sp>
-      <p:sp>
-        <p:nvSpPr>
-          <p:cNvPr id="49" name="TextBox 48"/>
-          <p:cNvSpPr txBox="1"/>
-          <p:nvPr/>
-        </p:nvSpPr>
-        <p:spPr>
-          <a:xfrm>
-            <a:off x="10058400" y="5980176"/>
-            <a:ext cx="1097280" cy="329184"/>
-          </a:xfrm>
-          <a:prstGeom prst="rect">
-            <a:avLst/>
-          </a:prstGeom>
-          <a:noFill/>
-        </p:spPr>
-        <p:txBody>
-          <a:bodyPr wrap="square" lIns="0" rIns="0" tIns="0" bIns="0">
-            <a:spAutoFit/>
-          </a:bodyPr>
-          <a:lstStyle/>
-          <a:p>
-            <a:pPr algn="l">
-              <a:lnSpc>
-                <a:spcPts val="1725"/>
-              </a:lnSpc>
-              <a:spcAft>
-                <a:spcPts val="0"/>
-              </a:spcAft>
-            </a:pPr>
-            <a:r>
-              <a:rPr sz="1150" b="1" i="0">
-                <a:solidFill>
-                  <a:srgbClr val="1A2430"/>
-                </a:solidFill>
-                <a:latin typeface="Garamond"/>
-              </a:rPr>
-              <a:t>19.4</a:t>
-            </a:r>
-          </a:p>
-        </p:txBody>
-      </p:sp>
-      <p:sp>
-        <p:nvSpPr>
-          <p:cNvPr id="50" name="TextBox 49"/>
-          <p:cNvSpPr txBox="1"/>
-          <p:nvPr/>
-        </p:nvSpPr>
-        <p:spPr>
-          <a:xfrm>
-            <a:off x="1005840" y="6309360"/>
-            <a:ext cx="2834640" cy="329184"/>
-          </a:xfrm>
-          <a:prstGeom prst="rect">
-            <a:avLst/>
-          </a:prstGeom>
-          <a:noFill/>
-        </p:spPr>
-        <p:txBody>
-          <a:bodyPr wrap="square" lIns="0" rIns="0" tIns="0" bIns="0">
-            <a:spAutoFit/>
-          </a:bodyPr>
-          <a:lstStyle/>
-          <a:p>
-            <a:pPr algn="l">
-              <a:lnSpc>
-                <a:spcPts val="1725"/>
-              </a:lnSpc>
-              <a:spcAft>
-                <a:spcPts val="0"/>
-              </a:spcAft>
-            </a:pPr>
-            <a:r>
-              <a:rPr sz="1150" b="1" i="0">
-                <a:solidFill>
-                  <a:srgbClr val="1A2430"/>
-                </a:solidFill>
-                <a:latin typeface="Garamond"/>
-              </a:rPr>
-              <a:t>NCES Teacher Follow-up Survey</a:t>
-            </a:r>
-          </a:p>
-        </p:txBody>
-      </p:sp>
-      <p:sp>
-        <p:nvSpPr>
-          <p:cNvPr id="51" name="TextBox 50"/>
-          <p:cNvSpPr txBox="1"/>
-          <p:nvPr/>
-        </p:nvSpPr>
-        <p:spPr>
-          <a:xfrm>
-            <a:off x="3977639" y="6309360"/>
-            <a:ext cx="5852160" cy="329184"/>
-          </a:xfrm>
-          <a:prstGeom prst="rect">
-            <a:avLst/>
-          </a:prstGeom>
-          <a:noFill/>
-        </p:spPr>
-        <p:txBody>
-          <a:bodyPr wrap="square" lIns="0" rIns="0" tIns="0" bIns="0">
-            <a:spAutoFit/>
-          </a:bodyPr>
-          <a:lstStyle/>
-          <a:p>
-            <a:pPr algn="l">
-              <a:lnSpc>
-                <a:spcPts val="1725"/>
-              </a:lnSpc>
-              <a:spcAft>
-                <a:spcPts val="0"/>
-              </a:spcAft>
-            </a:pPr>
-            <a:r>
-              <a:rPr sz="1150" b="0" i="0">
-                <a:solidFill>
-                  <a:srgbClr val="1A2430"/>
-                </a:solidFill>
-                <a:latin typeface="Garamond"/>
-              </a:rPr>
-              <a:t>roster-based re-survey of a teacher sample; wave 2021–22</a:t>
-            </a:r>
-          </a:p>
-        </p:txBody>
-      </p:sp>
-      <p:sp>
-        <p:nvSpPr>
-          <p:cNvPr id="52" name="TextBox 51"/>
-          <p:cNvSpPr txBox="1"/>
-          <p:nvPr/>
-        </p:nvSpPr>
-        <p:spPr>
-          <a:xfrm>
-            <a:off x="10058400" y="6309360"/>
-            <a:ext cx="1097280" cy="329184"/>
-          </a:xfrm>
-          <a:prstGeom prst="rect">
-            <a:avLst/>
-          </a:prstGeom>
-          <a:noFill/>
-        </p:spPr>
-        <p:txBody>
-          <a:bodyPr wrap="square" lIns="0" rIns="0" tIns="0" bIns="0">
-            <a:spAutoFit/>
-          </a:bodyPr>
-          <a:lstStyle/>
-          <a:p>
-            <a:pPr algn="l">
-              <a:lnSpc>
-                <a:spcPts val="1725"/>
-              </a:lnSpc>
-              <a:spcAft>
-                <a:spcPts val="0"/>
-              </a:spcAft>
-            </a:pPr>
-            <a:r>
-              <a:rPr sz="1150" b="1" i="0">
+              <a:rPr sz="1200" b="1" i="0">
                 <a:solidFill>
                   <a:srgbClr val="1A2430"/>
                 </a:solidFill>
@@ -13137,7 +13298,7 @@
       </p:sp>
       <p:cxnSp>
         <p:nvCxnSpPr>
-          <p:cNvPr id="53" name="Connector 52"/>
+          <p:cNvPr id="47" name="Connector 46"/>
           <p:cNvCxnSpPr/>
           <p:nvPr/>
         </p:nvCxnSpPr>

</xml_diff>

<commit_message>
All-series chart: NCES restricted to sample window, homogeneous labels
NCES follow-up points before 1997 dropped so the benchmark only appears
inside the 1997-2024 sample window. Series labels shortened to a uniform
format with initial capitals (Any sighting, Month pairs, Definition 1,
Annual recall, NCES follow-up), and the definitions-slide table renamed
to match the chart one for one.

Co-Authored-By: Claude Fable 5 <noreply@anthropic.com>
Claude-Session: https://claude.ai/code/session_01DNzQPDcr3zfLTraMHUHqUn
</commit_message>
<xml_diff>
--- a/report/Proyect_US_v4.pptx
+++ b/report/Proyect_US_v4.pptx
@@ -11745,7 +11745,7 @@
                 </a:solidFill>
                 <a:latin typeface="Garamond"/>
               </a:rPr>
-              <a:t>Definition 1, as above</a:t>
+              <a:t>Definition 1</a:t>
             </a:r>
           </a:p>
         </p:txBody>
@@ -11829,7 +11829,7 @@
                 </a:solidFill>
                 <a:latin typeface="Garamond"/>
               </a:rPr>
-              <a:t>Retrospective annual measure</a:t>
+              <a:t>Annual recall</a:t>
             </a:r>
           </a:p>
         </p:txBody>
@@ -11913,7 +11913,7 @@
                 </a:solidFill>
                 <a:latin typeface="Garamond"/>
               </a:rPr>
-              <a:t>Occupation-pair measure</a:t>
+              <a:t>Occupation pair</a:t>
             </a:r>
           </a:p>
         </p:txBody>
@@ -11997,7 +11997,7 @@
                 </a:solidFill>
                 <a:latin typeface="Garamond"/>
               </a:rPr>
-              <a:t>Month-pair measure</a:t>
+              <a:t>Month pairs</a:t>
             </a:r>
           </a:p>
         </p:txBody>
@@ -12081,7 +12081,7 @@
                 </a:solidFill>
                 <a:latin typeface="Garamond"/>
               </a:rPr>
-              <a:t>Any-sighting measure</a:t>
+              <a:t>Any sighting</a:t>
             </a:r>
           </a:p>
         </p:txBody>
@@ -12165,7 +12165,7 @@
                 </a:solidFill>
                 <a:latin typeface="Garamond"/>
               </a:rPr>
-              <a:t>NCES Teacher Follow-up Survey</a:t>
+              <a:t>NCES follow-up survey</a:t>
             </a:r>
           </a:p>
         </p:txBody>

</xml_diff>